<commit_message>
Documentation updated to include docker MySQL.
</commit_message>
<xml_diff>
--- a/docs/religious-texts-overview.pptx
+++ b/docs/religious-texts-overview.pptx
@@ -1417,8 +1417,8 @@
         </p:nvSpPr>
         <p:spPr>
           <a:xfrm>
-            <a:off x="0" y="4389120"/>
-            <a:ext cx="12161520" cy="73152"/>
+            <a:off x="0" y="4411980"/>
+            <a:ext cx="9144000" cy="73152"/>
           </a:xfrm>
           <a:prstGeom prst="rect">
             <a:avLst/>
@@ -1437,8 +1437,8 @@
         </p:nvSpPr>
         <p:spPr>
           <a:xfrm>
-            <a:off x="731520" y="1463040"/>
-            <a:ext cx="10698480" cy="1645920"/>
+            <a:off x="274320" y="1097280"/>
+            <a:ext cx="8595360" cy="1463040"/>
           </a:xfrm>
           <a:prstGeom prst="rect">
             <a:avLst/>
@@ -1454,7 +1454,7 @@
               <a:buNone/>
             </a:pPr>
             <a:r>
-              <a:rPr lang="en-US" sz="5200" b="1" dirty="0">
+              <a:rPr lang="en-US" sz="4400" b="1" dirty="0">
                 <a:solidFill>
                   <a:srgbClr val="FFFFFF"/>
                 </a:solidFill>
@@ -1464,7 +1464,7 @@
               </a:rPr>
               <a:t>Religious Texts Platform</a:t>
             </a:r>
-            <a:endParaRPr lang="en-US" sz="5200" dirty="0"/>
+            <a:endParaRPr lang="en-US" sz="4400" dirty="0"/>
           </a:p>
         </p:txBody>
       </p:sp>
@@ -1476,8 +1476,8 @@
         </p:nvSpPr>
         <p:spPr>
           <a:xfrm>
-            <a:off x="731520" y="3200400"/>
-            <a:ext cx="10698480" cy="731520"/>
+            <a:off x="274320" y="2651760"/>
+            <a:ext cx="8595360" cy="731520"/>
           </a:xfrm>
           <a:prstGeom prst="rect">
             <a:avLst/>
@@ -1493,7 +1493,7 @@
               <a:buNone/>
             </a:pPr>
             <a:r>
-              <a:rPr lang="en-US" sz="2200" i="1" dirty="0">
+              <a:rPr lang="en-US" sz="1800" i="1" dirty="0">
                 <a:solidFill>
                   <a:srgbClr val="C9A84C"/>
                 </a:solidFill>
@@ -1503,7 +1503,7 @@
               </a:rPr>
               <a:t>A multi-tradition study reader for Bible, Quran, Hadith &amp; Commentary</a:t>
             </a:r>
-            <a:endParaRPr lang="en-US" sz="2200" dirty="0"/>
+            <a:endParaRPr lang="en-US" sz="1800" dirty="0"/>
           </a:p>
         </p:txBody>
       </p:sp>
@@ -1515,8 +1515,8 @@
         </p:nvSpPr>
         <p:spPr>
           <a:xfrm>
-            <a:off x="731520" y="4663440"/>
-            <a:ext cx="10698480" cy="365760"/>
+            <a:off x="274320" y="4503420"/>
+            <a:ext cx="8595360" cy="365760"/>
           </a:xfrm>
           <a:prstGeom prst="rect">
             <a:avLst/>
@@ -1532,7 +1532,7 @@
               <a:buNone/>
             </a:pPr>
             <a:r>
-              <a:rPr lang="en-US" sz="1400" dirty="0">
+              <a:rPr lang="en-US" sz="1300" dirty="0">
                 <a:solidFill>
                   <a:srgbClr val="FFFFFF"/>
                 </a:solidFill>
@@ -1542,7 +1542,7 @@
               </a:rPr>
               <a:t>May 2026</a:t>
             </a:r>
-            <a:endParaRPr lang="en-US" sz="1400" dirty="0"/>
+            <a:endParaRPr lang="en-US" sz="1300" dirty="0"/>
           </a:p>
         </p:txBody>
       </p:sp>
@@ -1587,7 +1587,7 @@
         <p:spPr>
           <a:xfrm>
             <a:off x="0" y="0"/>
-            <a:ext cx="12161520" cy="822960"/>
+            <a:ext cx="9144000" cy="685800"/>
           </a:xfrm>
           <a:prstGeom prst="rect">
             <a:avLst/>
@@ -1606,8 +1606,8 @@
         </p:nvSpPr>
         <p:spPr>
           <a:xfrm>
-            <a:off x="0" y="822960"/>
-            <a:ext cx="12161520" cy="54864"/>
+            <a:off x="0" y="685800"/>
+            <a:ext cx="9144000" cy="45720"/>
           </a:xfrm>
           <a:prstGeom prst="rect">
             <a:avLst/>
@@ -1626,8 +1626,8 @@
         </p:nvSpPr>
         <p:spPr>
           <a:xfrm>
-            <a:off x="365760" y="45720"/>
-            <a:ext cx="11430000" cy="731520"/>
+            <a:off x="274320" y="45720"/>
+            <a:ext cx="8595360" cy="594360"/>
           </a:xfrm>
           <a:prstGeom prst="rect">
             <a:avLst/>
@@ -1643,7 +1643,7 @@
               <a:buNone/>
             </a:pPr>
             <a:r>
-              <a:rPr lang="en-US" sz="2400" b="1" dirty="0">
+              <a:rPr lang="en-US" sz="2200" b="1" dirty="0">
                 <a:solidFill>
                   <a:srgbClr val="FFFFFF"/>
                 </a:solidFill>
@@ -1653,7 +1653,7 @@
               </a:rPr>
               <a:t>What Is the Religious Texts Platform?</a:t>
             </a:r>
-            <a:endParaRPr lang="en-US" sz="2400" dirty="0"/>
+            <a:endParaRPr lang="en-US" sz="2200" dirty="0"/>
           </a:p>
         </p:txBody>
       </p:sp>
@@ -1665,8 +1665,8 @@
         </p:nvSpPr>
         <p:spPr>
           <a:xfrm>
-            <a:off x="457200" y="1005840"/>
-            <a:ext cx="11247120" cy="548640"/>
+            <a:off x="274320" y="822960"/>
+            <a:ext cx="8595360" cy="457200"/>
           </a:xfrm>
           <a:prstGeom prst="rect">
             <a:avLst/>
@@ -1682,7 +1682,7 @@
               <a:buNone/>
             </a:pPr>
             <a:r>
-              <a:rPr lang="en-US" sz="1700" i="1" dirty="0">
+              <a:rPr lang="en-US" sz="1500" i="1" dirty="0">
                 <a:solidFill>
                   <a:srgbClr val="1A3A5C"/>
                 </a:solidFill>
@@ -1692,7 +1692,7 @@
               </a:rPr>
               <a:t>A web-based reader for studying religious texts side-by-side across traditions, translations, and languages.</a:t>
             </a:r>
-            <a:endParaRPr lang="en-US" sz="1700" dirty="0"/>
+            <a:endParaRPr lang="en-US" sz="1500" dirty="0"/>
           </a:p>
         </p:txBody>
       </p:sp>
@@ -1704,8 +1704,8 @@
         </p:nvSpPr>
         <p:spPr>
           <a:xfrm>
-            <a:off x="274320" y="1691640"/>
-            <a:ext cx="2651760" cy="2560320"/>
+            <a:off x="274320" y="1417320"/>
+            <a:ext cx="2080260" cy="3383280"/>
           </a:xfrm>
           <a:prstGeom prst="rect">
             <a:avLst/>
@@ -1720,7 +1720,7 @@
             <a:prstDash val="solid"/>
           </a:ln>
           <a:effectLst>
-            <a:outerShdw sx="100000" sy="100000" kx="0" ky="0" algn="bl" rotWithShape="0" blurRad="50800" dist="25400" dir="2700000">
+            <a:outerShdw sx="100000" sy="100000" kx="0" ky="0" algn="bl" rotWithShape="0" blurRad="38100" dist="25400" dir="2700000">
               <a:srgbClr val="CCCCCC">
                 <a:alpha val="30000"/>
               </a:srgbClr>
@@ -1736,8 +1736,8 @@
         </p:nvSpPr>
         <p:spPr>
           <a:xfrm>
-            <a:off x="274320" y="1691640"/>
-            <a:ext cx="2651760" cy="54864"/>
+            <a:off x="274320" y="1417320"/>
+            <a:ext cx="2080260" cy="45720"/>
           </a:xfrm>
           <a:prstGeom prst="rect">
             <a:avLst/>
@@ -1756,8 +1756,8 @@
         </p:nvSpPr>
         <p:spPr>
           <a:xfrm>
-            <a:off x="274320" y="1828800"/>
-            <a:ext cx="2651760" cy="457200"/>
+            <a:off x="274320" y="1508760"/>
+            <a:ext cx="2080260" cy="411480"/>
           </a:xfrm>
           <a:prstGeom prst="rect">
             <a:avLst/>
@@ -1773,14 +1773,14 @@
               <a:buNone/>
             </a:pPr>
             <a:r>
-              <a:rPr lang="en-US" sz="2600" dirty="0">
+              <a:rPr lang="en-US" sz="2200" dirty="0">
                 <a:solidFill>
                   <a:srgbClr val="000000"/>
                 </a:solidFill>
               </a:rPr>
               <a:t>📖</a:t>
             </a:r>
-            <a:endParaRPr lang="en-US" sz="2600" dirty="0"/>
+            <a:endParaRPr lang="en-US" sz="2200" dirty="0"/>
           </a:p>
         </p:txBody>
       </p:sp>
@@ -1792,8 +1792,8 @@
         </p:nvSpPr>
         <p:spPr>
           <a:xfrm>
-            <a:off x="411480" y="2286000"/>
-            <a:ext cx="2377440" cy="320040"/>
+            <a:off x="365760" y="1920240"/>
+            <a:ext cx="1897380" cy="274320"/>
           </a:xfrm>
           <a:prstGeom prst="rect">
             <a:avLst/>
@@ -1809,7 +1809,7 @@
               <a:buNone/>
             </a:pPr>
             <a:r>
-              <a:rPr lang="en-US" sz="1400" b="1" dirty="0">
+              <a:rPr lang="en-US" sz="1300" b="1" dirty="0">
                 <a:solidFill>
                   <a:srgbClr val="1A3A5C"/>
                 </a:solidFill>
@@ -1819,7 +1819,7 @@
               </a:rPr>
               <a:t>Multi-Column</a:t>
             </a:r>
-            <a:endParaRPr lang="en-US" sz="1400" dirty="0"/>
+            <a:endParaRPr lang="en-US" sz="1300" dirty="0"/>
           </a:p>
         </p:txBody>
       </p:sp>
@@ -1831,8 +1831,8 @@
         </p:nvSpPr>
         <p:spPr>
           <a:xfrm>
-            <a:off x="411480" y="2606040"/>
-            <a:ext cx="2377440" cy="1508760"/>
+            <a:off x="365760" y="2194560"/>
+            <a:ext cx="1897380" cy="2514600"/>
           </a:xfrm>
           <a:prstGeom prst="rect">
             <a:avLst/>
@@ -1848,7 +1848,7 @@
               <a:buNone/>
             </a:pPr>
             <a:r>
-              <a:rPr lang="en-US" sz="1100" dirty="0">
+              <a:rPr lang="en-US" sz="1000" dirty="0">
                 <a:solidFill>
                   <a:srgbClr val="666666"/>
                 </a:solidFill>
@@ -1858,7 +1858,7 @@
               </a:rPr>
               <a:t>Open any combination of Bible translations, Quran, Hadith, and commentaries simultaneously</a:t>
             </a:r>
-            <a:endParaRPr lang="en-US" sz="1100" dirty="0"/>
+            <a:endParaRPr lang="en-US" sz="1000" dirty="0"/>
           </a:p>
         </p:txBody>
       </p:sp>
@@ -1870,8 +1870,8 @@
         </p:nvSpPr>
         <p:spPr>
           <a:xfrm>
-            <a:off x="3063240" y="1691640"/>
-            <a:ext cx="2651760" cy="2560320"/>
+            <a:off x="2446020" y="1417320"/>
+            <a:ext cx="2080260" cy="3383280"/>
           </a:xfrm>
           <a:prstGeom prst="rect">
             <a:avLst/>
@@ -1886,7 +1886,7 @@
             <a:prstDash val="solid"/>
           </a:ln>
           <a:effectLst>
-            <a:outerShdw sx="100000" sy="100000" kx="0" ky="0" algn="bl" rotWithShape="0" blurRad="50800" dist="25400" dir="2700000">
+            <a:outerShdw sx="100000" sy="100000" kx="0" ky="0" algn="bl" rotWithShape="0" blurRad="38100" dist="25400" dir="2700000">
               <a:srgbClr val="CCCCCC">
                 <a:alpha val="30000"/>
               </a:srgbClr>
@@ -1902,8 +1902,8 @@
         </p:nvSpPr>
         <p:spPr>
           <a:xfrm>
-            <a:off x="3063240" y="1691640"/>
-            <a:ext cx="2651760" cy="54864"/>
+            <a:off x="2446020" y="1417320"/>
+            <a:ext cx="2080260" cy="45720"/>
           </a:xfrm>
           <a:prstGeom prst="rect">
             <a:avLst/>
@@ -1922,8 +1922,8 @@
         </p:nvSpPr>
         <p:spPr>
           <a:xfrm>
-            <a:off x="3063240" y="1828800"/>
-            <a:ext cx="2651760" cy="457200"/>
+            <a:off x="2446020" y="1508760"/>
+            <a:ext cx="2080260" cy="411480"/>
           </a:xfrm>
           <a:prstGeom prst="rect">
             <a:avLst/>
@@ -1939,14 +1939,14 @@
               <a:buNone/>
             </a:pPr>
             <a:r>
-              <a:rPr lang="en-US" sz="2600" dirty="0">
+              <a:rPr lang="en-US" sz="2200" dirty="0">
                 <a:solidFill>
                   <a:srgbClr val="000000"/>
                 </a:solidFill>
               </a:rPr>
               <a:t>🌍</a:t>
             </a:r>
-            <a:endParaRPr lang="en-US" sz="2600" dirty="0"/>
+            <a:endParaRPr lang="en-US" sz="2200" dirty="0"/>
           </a:p>
         </p:txBody>
       </p:sp>
@@ -1958,8 +1958,8 @@
         </p:nvSpPr>
         <p:spPr>
           <a:xfrm>
-            <a:off x="3200400" y="2286000"/>
-            <a:ext cx="2377440" cy="320040"/>
+            <a:off x="2537460" y="1920240"/>
+            <a:ext cx="1897380" cy="274320"/>
           </a:xfrm>
           <a:prstGeom prst="rect">
             <a:avLst/>
@@ -1975,7 +1975,7 @@
               <a:buNone/>
             </a:pPr>
             <a:r>
-              <a:rPr lang="en-US" sz="1400" b="1" dirty="0">
+              <a:rPr lang="en-US" sz="1300" b="1" dirty="0">
                 <a:solidFill>
                   <a:srgbClr val="1A3A5C"/>
                 </a:solidFill>
@@ -1985,7 +1985,7 @@
               </a:rPr>
               <a:t>Multi-Language</a:t>
             </a:r>
-            <a:endParaRPr lang="en-US" sz="1400" dirty="0"/>
+            <a:endParaRPr lang="en-US" sz="1300" dirty="0"/>
           </a:p>
         </p:txBody>
       </p:sp>
@@ -1997,8 +1997,8 @@
         </p:nvSpPr>
         <p:spPr>
           <a:xfrm>
-            <a:off x="3200400" y="2606040"/>
-            <a:ext cx="2377440" cy="1508760"/>
+            <a:off x="2537460" y="2194560"/>
+            <a:ext cx="1897380" cy="2514600"/>
           </a:xfrm>
           <a:prstGeom prst="rect">
             <a:avLst/>
@@ -2014,7 +2014,7 @@
               <a:buNone/>
             </a:pPr>
             <a:r>
-              <a:rPr lang="en-US" sz="1100" dirty="0">
+              <a:rPr lang="en-US" sz="1000" dirty="0">
                 <a:solidFill>
                   <a:srgbClr val="666666"/>
                 </a:solidFill>
@@ -2024,7 +2024,7 @@
               </a:rPr>
               <a:t>Texts in English, Spanish, German, Greek, Hebrew, Arabic and more</a:t>
             </a:r>
-            <a:endParaRPr lang="en-US" sz="1100" dirty="0"/>
+            <a:endParaRPr lang="en-US" sz="1000" dirty="0"/>
           </a:p>
         </p:txBody>
       </p:sp>
@@ -2036,8 +2036,8 @@
         </p:nvSpPr>
         <p:spPr>
           <a:xfrm>
-            <a:off x="5852160" y="1691640"/>
-            <a:ext cx="2651760" cy="2560320"/>
+            <a:off x="4617720" y="1417320"/>
+            <a:ext cx="2080260" cy="3383280"/>
           </a:xfrm>
           <a:prstGeom prst="rect">
             <a:avLst/>
@@ -2052,7 +2052,7 @@
             <a:prstDash val="solid"/>
           </a:ln>
           <a:effectLst>
-            <a:outerShdw sx="100000" sy="100000" kx="0" ky="0" algn="bl" rotWithShape="0" blurRad="50800" dist="25400" dir="2700000">
+            <a:outerShdw sx="100000" sy="100000" kx="0" ky="0" algn="bl" rotWithShape="0" blurRad="38100" dist="25400" dir="2700000">
               <a:srgbClr val="CCCCCC">
                 <a:alpha val="30000"/>
               </a:srgbClr>
@@ -2068,8 +2068,8 @@
         </p:nvSpPr>
         <p:spPr>
           <a:xfrm>
-            <a:off x="5852160" y="1691640"/>
-            <a:ext cx="2651760" cy="54864"/>
+            <a:off x="4617720" y="1417320"/>
+            <a:ext cx="2080260" cy="45720"/>
           </a:xfrm>
           <a:prstGeom prst="rect">
             <a:avLst/>
@@ -2088,8 +2088,8 @@
         </p:nvSpPr>
         <p:spPr>
           <a:xfrm>
-            <a:off x="5852160" y="1828800"/>
-            <a:ext cx="2651760" cy="457200"/>
+            <a:off x="4617720" y="1508760"/>
+            <a:ext cx="2080260" cy="411480"/>
           </a:xfrm>
           <a:prstGeom prst="rect">
             <a:avLst/>
@@ -2105,14 +2105,14 @@
               <a:buNone/>
             </a:pPr>
             <a:r>
-              <a:rPr lang="en-US" sz="2600" dirty="0">
+              <a:rPr lang="en-US" sz="2200" dirty="0">
                 <a:solidFill>
                   <a:srgbClr val="000000"/>
                 </a:solidFill>
               </a:rPr>
               <a:t>🔗</a:t>
             </a:r>
-            <a:endParaRPr lang="en-US" sz="2600" dirty="0"/>
+            <a:endParaRPr lang="en-US" sz="2200" dirty="0"/>
           </a:p>
         </p:txBody>
       </p:sp>
@@ -2124,8 +2124,8 @@
         </p:nvSpPr>
         <p:spPr>
           <a:xfrm>
-            <a:off x="5989320" y="2286000"/>
-            <a:ext cx="2377440" cy="320040"/>
+            <a:off x="4709160" y="1920240"/>
+            <a:ext cx="1897380" cy="274320"/>
           </a:xfrm>
           <a:prstGeom prst="rect">
             <a:avLst/>
@@ -2141,7 +2141,7 @@
               <a:buNone/>
             </a:pPr>
             <a:r>
-              <a:rPr lang="en-US" sz="1400" b="1" dirty="0">
+              <a:rPr lang="en-US" sz="1300" b="1" dirty="0">
                 <a:solidFill>
                   <a:srgbClr val="1A3A5C"/>
                 </a:solidFill>
@@ -2151,7 +2151,7 @@
               </a:rPr>
               <a:t>Cross-Referenced</a:t>
             </a:r>
-            <a:endParaRPr lang="en-US" sz="1400" dirty="0"/>
+            <a:endParaRPr lang="en-US" sz="1300" dirty="0"/>
           </a:p>
         </p:txBody>
       </p:sp>
@@ -2163,8 +2163,8 @@
         </p:nvSpPr>
         <p:spPr>
           <a:xfrm>
-            <a:off x="5989320" y="2606040"/>
-            <a:ext cx="2377440" cy="1508760"/>
+            <a:off x="4709160" y="2194560"/>
+            <a:ext cx="1897380" cy="2514600"/>
           </a:xfrm>
           <a:prstGeom prst="rect">
             <a:avLst/>
@@ -2180,7 +2180,7 @@
               <a:buNone/>
             </a:pPr>
             <a:r>
-              <a:rPr lang="en-US" sz="1100" dirty="0">
+              <a:rPr lang="en-US" sz="1000" dirty="0">
                 <a:solidFill>
                   <a:srgbClr val="666666"/>
                 </a:solidFill>
@@ -2190,7 +2190,7 @@
               </a:rPr>
               <a:t>Commentary links jump to the exact verse in every open translation at once</a:t>
             </a:r>
-            <a:endParaRPr lang="en-US" sz="1100" dirty="0"/>
+            <a:endParaRPr lang="en-US" sz="1000" dirty="0"/>
           </a:p>
         </p:txBody>
       </p:sp>
@@ -2202,8 +2202,8 @@
         </p:nvSpPr>
         <p:spPr>
           <a:xfrm>
-            <a:off x="8641080" y="1691640"/>
-            <a:ext cx="2651760" cy="2560320"/>
+            <a:off x="6789420" y="1417320"/>
+            <a:ext cx="2080260" cy="3383280"/>
           </a:xfrm>
           <a:prstGeom prst="rect">
             <a:avLst/>
@@ -2218,7 +2218,7 @@
             <a:prstDash val="solid"/>
           </a:ln>
           <a:effectLst>
-            <a:outerShdw sx="100000" sy="100000" kx="0" ky="0" algn="bl" rotWithShape="0" blurRad="50800" dist="25400" dir="2700000">
+            <a:outerShdw sx="100000" sy="100000" kx="0" ky="0" algn="bl" rotWithShape="0" blurRad="38100" dist="25400" dir="2700000">
               <a:srgbClr val="CCCCCC">
                 <a:alpha val="30000"/>
               </a:srgbClr>
@@ -2234,8 +2234,8 @@
         </p:nvSpPr>
         <p:spPr>
           <a:xfrm>
-            <a:off x="8641080" y="1691640"/>
-            <a:ext cx="2651760" cy="54864"/>
+            <a:off x="6789420" y="1417320"/>
+            <a:ext cx="2080260" cy="45720"/>
           </a:xfrm>
           <a:prstGeom prst="rect">
             <a:avLst/>
@@ -2254,8 +2254,8 @@
         </p:nvSpPr>
         <p:spPr>
           <a:xfrm>
-            <a:off x="8641080" y="1828800"/>
-            <a:ext cx="2651760" cy="457200"/>
+            <a:off x="6789420" y="1508760"/>
+            <a:ext cx="2080260" cy="411480"/>
           </a:xfrm>
           <a:prstGeom prst="rect">
             <a:avLst/>
@@ -2271,14 +2271,14 @@
               <a:buNone/>
             </a:pPr>
             <a:r>
-              <a:rPr lang="en-US" sz="2600" dirty="0">
+              <a:rPr lang="en-US" sz="2200" dirty="0">
                 <a:solidFill>
                   <a:srgbClr val="000000"/>
                 </a:solidFill>
               </a:rPr>
               <a:t>📝</a:t>
             </a:r>
-            <a:endParaRPr lang="en-US" sz="2600" dirty="0"/>
+            <a:endParaRPr lang="en-US" sz="2200" dirty="0"/>
           </a:p>
         </p:txBody>
       </p:sp>
@@ -2290,8 +2290,8 @@
         </p:nvSpPr>
         <p:spPr>
           <a:xfrm>
-            <a:off x="8778240" y="2286000"/>
-            <a:ext cx="2377440" cy="320040"/>
+            <a:off x="6880860" y="1920240"/>
+            <a:ext cx="1897380" cy="274320"/>
           </a:xfrm>
           <a:prstGeom prst="rect">
             <a:avLst/>
@@ -2307,7 +2307,7 @@
               <a:buNone/>
             </a:pPr>
             <a:r>
-              <a:rPr lang="en-US" sz="1400" b="1" dirty="0">
+              <a:rPr lang="en-US" sz="1300" b="1" dirty="0">
                 <a:solidFill>
                   <a:srgbClr val="1A3A5C"/>
                 </a:solidFill>
@@ -2317,7 +2317,7 @@
               </a:rPr>
               <a:t>Personal Notes</a:t>
             </a:r>
-            <a:endParaRPr lang="en-US" sz="1400" dirty="0"/>
+            <a:endParaRPr lang="en-US" sz="1300" dirty="0"/>
           </a:p>
         </p:txBody>
       </p:sp>
@@ -2329,8 +2329,8 @@
         </p:nvSpPr>
         <p:spPr>
           <a:xfrm>
-            <a:off x="8778240" y="2606040"/>
-            <a:ext cx="2377440" cy="1508760"/>
+            <a:off x="6880860" y="2194560"/>
+            <a:ext cx="1897380" cy="2514600"/>
           </a:xfrm>
           <a:prstGeom prst="rect">
             <a:avLst/>
@@ -2346,7 +2346,7 @@
               <a:buNone/>
             </a:pPr>
             <a:r>
-              <a:rPr lang="en-US" sz="1100" dirty="0">
+              <a:rPr lang="en-US" sz="1000" dirty="0">
                 <a:solidFill>
                   <a:srgbClr val="666666"/>
                 </a:solidFill>
@@ -2356,7 +2356,7 @@
               </a:rPr>
               <a:t>Add your own annotations and comments alongside the texts</a:t>
             </a:r>
-            <a:endParaRPr lang="en-US" sz="1100" dirty="0"/>
+            <a:endParaRPr lang="en-US" sz="1000" dirty="0"/>
           </a:p>
         </p:txBody>
       </p:sp>
@@ -2401,7 +2401,7 @@
         <p:spPr>
           <a:xfrm>
             <a:off x="0" y="0"/>
-            <a:ext cx="12161520" cy="822960"/>
+            <a:ext cx="9144000" cy="685800"/>
           </a:xfrm>
           <a:prstGeom prst="rect">
             <a:avLst/>
@@ -2420,8 +2420,8 @@
         </p:nvSpPr>
         <p:spPr>
           <a:xfrm>
-            <a:off x="0" y="822960"/>
-            <a:ext cx="12161520" cy="54864"/>
+            <a:off x="0" y="685800"/>
+            <a:ext cx="9144000" cy="45720"/>
           </a:xfrm>
           <a:prstGeom prst="rect">
             <a:avLst/>
@@ -2440,8 +2440,8 @@
         </p:nvSpPr>
         <p:spPr>
           <a:xfrm>
-            <a:off x="365760" y="45720"/>
-            <a:ext cx="11430000" cy="731520"/>
+            <a:off x="274320" y="45720"/>
+            <a:ext cx="8595360" cy="594360"/>
           </a:xfrm>
           <a:prstGeom prst="rect">
             <a:avLst/>
@@ -2457,7 +2457,7 @@
               <a:buNone/>
             </a:pPr>
             <a:r>
-              <a:rPr lang="en-US" sz="2400" b="1" dirty="0">
+              <a:rPr lang="en-US" sz="2200" b="1" dirty="0">
                 <a:solidFill>
                   <a:srgbClr val="FFFFFF"/>
                 </a:solidFill>
@@ -2467,7 +2467,7 @@
               </a:rPr>
               <a:t>The Vision</a:t>
             </a:r>
-            <a:endParaRPr lang="en-US" sz="2400" dirty="0"/>
+            <a:endParaRPr lang="en-US" sz="2200" dirty="0"/>
           </a:p>
         </p:txBody>
       </p:sp>
@@ -2479,8 +2479,8 @@
         </p:nvSpPr>
         <p:spPr>
           <a:xfrm>
-            <a:off x="457200" y="960120"/>
-            <a:ext cx="11247120" cy="914400"/>
+            <a:off x="274320" y="777240"/>
+            <a:ext cx="8595360" cy="640080"/>
           </a:xfrm>
           <a:prstGeom prst="rect">
             <a:avLst/>
@@ -2496,7 +2496,7 @@
               <a:buNone/>
             </a:pPr>
             <a:r>
-              <a:rPr lang="en-US" sz="1600" dirty="0">
+              <a:rPr lang="en-US" sz="1400" dirty="0">
                 <a:solidFill>
                   <a:srgbClr val="666666"/>
                 </a:solidFill>
@@ -2510,7 +2510,7 @@
               <a:buNone/>
             </a:pPr>
             <a:r>
-              <a:rPr lang="en-US" sz="1600" b="1" dirty="0">
+              <a:rPr lang="en-US" sz="1400" b="1" dirty="0">
                 <a:solidFill>
                   <a:srgbClr val="1A3A5C"/>
                 </a:solidFill>
@@ -2524,7 +2524,7 @@
               <a:buNone/>
             </a:pPr>
             <a:r>
-              <a:rPr lang="en-US" sz="1600" dirty="0">
+              <a:rPr lang="en-US" sz="1400" dirty="0">
                 <a:solidFill>
                   <a:srgbClr val="666666"/>
                 </a:solidFill>
@@ -2532,13 +2532,13 @@
                 <a:ea typeface="Arial" pitchFamily="34" charset="-122"/>
                 <a:cs typeface="Arial" pitchFamily="34" charset="-120"/>
               </a:rPr>
-              <a:t> in the NIV and KJV side by side, while a </a:t>
+              <a:t> in NIV and KJV side by side, while a </a:t>
             </a:r>
             <a:pPr indent="0" marL="0">
               <a:buNone/>
             </a:pPr>
             <a:r>
-              <a:rPr lang="en-US" sz="1600" b="1" dirty="0">
+              <a:rPr lang="en-US" sz="1400" b="1" dirty="0">
                 <a:solidFill>
                   <a:srgbClr val="1A3A5C"/>
                 </a:solidFill>
@@ -2552,7 +2552,7 @@
               <a:buNone/>
             </a:pPr>
             <a:r>
-              <a:rPr lang="en-US" sz="1600" dirty="0">
+              <a:rPr lang="en-US" sz="1400" dirty="0">
                 <a:solidFill>
                   <a:srgbClr val="666666"/>
                 </a:solidFill>
@@ -2560,13 +2560,13 @@
                 <a:ea typeface="Arial" pitchFamily="34" charset="-122"/>
                 <a:cs typeface="Arial" pitchFamily="34" charset="-120"/>
               </a:rPr>
-              <a:t> explains the Hebrew. Click a verse reference in the commentary and </a:t>
+              <a:t> explains the Hebrew. Click a reference — </a:t>
             </a:r>
             <a:pPr indent="0" marL="0">
               <a:buNone/>
             </a:pPr>
             <a:r>
-              <a:rPr lang="en-US" sz="1600" b="1" dirty="0">
+              <a:rPr lang="en-US" sz="1400" b="1" dirty="0">
                 <a:solidFill>
                   <a:srgbClr val="1A3A5C"/>
                 </a:solidFill>
@@ -2574,9 +2574,9 @@
                 <a:ea typeface="Arial" pitchFamily="34" charset="-122"/>
                 <a:cs typeface="Arial" pitchFamily="34" charset="-120"/>
               </a:rPr>
-              <a:t>both Bible columns jump to that verse instantly.</a:t>
-            </a:r>
-            <a:endParaRPr lang="en-US" sz="1600" dirty="0"/>
+              <a:t>both columns jump to that verse instantly.</a:t>
+            </a:r>
+            <a:endParaRPr lang="en-US" sz="1400" dirty="0"/>
           </a:p>
         </p:txBody>
       </p:sp>
@@ -2588,8 +2588,8 @@
         </p:nvSpPr>
         <p:spPr>
           <a:xfrm>
-            <a:off x="274320" y="2011680"/>
-            <a:ext cx="3474720" cy="2560320"/>
+            <a:off x="274320" y="1508760"/>
+            <a:ext cx="2651760" cy="3291840"/>
           </a:xfrm>
           <a:prstGeom prst="rect">
             <a:avLst/>
@@ -2607,14 +2607,14 @@
       </p:sp>
       <p:sp>
         <p:nvSpPr>
-          <p:cNvPr id="7" name="Text 5"/>
-          <p:cNvSpPr/>
-          <p:nvPr/>
-        </p:nvSpPr>
-        <p:spPr>
-          <a:xfrm>
-            <a:off x="274320" y="2011680"/>
-            <a:ext cx="3474720" cy="365760"/>
+          <p:cNvPr id="7" name="Shape 5"/>
+          <p:cNvSpPr/>
+          <p:nvPr/>
+        </p:nvSpPr>
+        <p:spPr>
+          <a:xfrm>
+            <a:off x="274320" y="1508760"/>
+            <a:ext cx="2651760" cy="320040"/>
           </a:xfrm>
           <a:prstGeom prst="rect">
             <a:avLst/>
@@ -2624,15 +2624,33 @@
           </a:solidFill>
           <a:ln/>
         </p:spPr>
-        <p:txBody>
-          <a:bodyPr wrap="square" rtlCol="0" anchor="ctr"/>
+      </p:sp>
+      <p:sp>
+        <p:nvSpPr>
+          <p:cNvPr id="8" name="Text 6"/>
+          <p:cNvSpPr/>
+          <p:nvPr/>
+        </p:nvSpPr>
+        <p:spPr>
+          <a:xfrm>
+            <a:off x="274320" y="1508760"/>
+            <a:ext cx="2651760" cy="320040"/>
+          </a:xfrm>
+          <a:prstGeom prst="rect">
+            <a:avLst/>
+          </a:prstGeom>
+          <a:noFill/>
+          <a:ln/>
+        </p:spPr>
+        <p:txBody>
+          <a:bodyPr wrap="square" lIns="0" tIns="0" rIns="0" bIns="0" rtlCol="0" anchor="ctr"/>
           <a:lstStyle/>
           <a:p>
             <a:pPr algn="ctr" indent="0" marL="0">
               <a:buNone/>
             </a:pPr>
             <a:r>
-              <a:rPr lang="en-US" sz="1300" b="1" dirty="0">
+              <a:rPr lang="en-US" sz="1200" b="1" dirty="0">
                 <a:solidFill>
                   <a:srgbClr val="FFFFFF"/>
                 </a:solidFill>
@@ -2642,46 +2660,7 @@
               </a:rPr>
               <a:t>NIV</a:t>
             </a:r>
-            <a:endParaRPr lang="en-US" sz="1300" dirty="0"/>
-          </a:p>
-        </p:txBody>
-      </p:sp>
-      <p:sp>
-        <p:nvSpPr>
-          <p:cNvPr id="8" name="Text 6"/>
-          <p:cNvSpPr/>
-          <p:nvPr/>
-        </p:nvSpPr>
-        <p:spPr>
-          <a:xfrm>
-            <a:off x="411480" y="2468880"/>
-            <a:ext cx="3200400" cy="2011680"/>
-          </a:xfrm>
-          <a:prstGeom prst="rect">
-            <a:avLst/>
-          </a:prstGeom>
-          <a:noFill/>
-          <a:ln/>
-        </p:spPr>
-        <p:txBody>
-          <a:bodyPr wrap="square" rtlCol="0" anchor="ctr"/>
-          <a:lstStyle/>
-          <a:p>
-            <a:pPr indent="0" marL="0">
-              <a:buNone/>
-            </a:pPr>
-            <a:r>
-              <a:rPr lang="en-US" sz="1100" dirty="0">
-                <a:solidFill>
-                  <a:srgbClr val="666666"/>
-                </a:solidFill>
-                <a:latin typeface="Arial" pitchFamily="34" charset="0"/>
-                <a:ea typeface="Arial" pitchFamily="34" charset="-122"/>
-                <a:cs typeface="Arial" pitchFamily="34" charset="-120"/>
-              </a:rPr>
-              <a:t>¹ In the beginning God created the heavens and the earth. ² Now the earth was formless and empty, darkness was over the surface of the deep...</a:t>
-            </a:r>
-            <a:endParaRPr lang="en-US" sz="1100" dirty="0"/>
+            <a:endParaRPr lang="en-US" sz="1200" dirty="0"/>
           </a:p>
         </p:txBody>
       </p:sp>
@@ -2693,8 +2672,8 @@
         </p:nvSpPr>
         <p:spPr>
           <a:xfrm>
-            <a:off x="4023360" y="2011680"/>
-            <a:ext cx="3474720" cy="2560320"/>
+            <a:off x="3063240" y="1508760"/>
+            <a:ext cx="2651760" cy="3291840"/>
           </a:xfrm>
           <a:prstGeom prst="rect">
             <a:avLst/>
@@ -2712,14 +2691,14 @@
       </p:sp>
       <p:sp>
         <p:nvSpPr>
-          <p:cNvPr id="10" name="Text 8"/>
-          <p:cNvSpPr/>
-          <p:nvPr/>
-        </p:nvSpPr>
-        <p:spPr>
-          <a:xfrm>
-            <a:off x="4023360" y="2011680"/>
-            <a:ext cx="3474720" cy="365760"/>
+          <p:cNvPr id="10" name="Shape 8"/>
+          <p:cNvSpPr/>
+          <p:nvPr/>
+        </p:nvSpPr>
+        <p:spPr>
+          <a:xfrm>
+            <a:off x="3063240" y="1508760"/>
+            <a:ext cx="2651760" cy="320040"/>
           </a:xfrm>
           <a:prstGeom prst="rect">
             <a:avLst/>
@@ -2729,15 +2708,33 @@
           </a:solidFill>
           <a:ln/>
         </p:spPr>
-        <p:txBody>
-          <a:bodyPr wrap="square" rtlCol="0" anchor="ctr"/>
+      </p:sp>
+      <p:sp>
+        <p:nvSpPr>
+          <p:cNvPr id="11" name="Text 9"/>
+          <p:cNvSpPr/>
+          <p:nvPr/>
+        </p:nvSpPr>
+        <p:spPr>
+          <a:xfrm>
+            <a:off x="3063240" y="1508760"/>
+            <a:ext cx="2651760" cy="320040"/>
+          </a:xfrm>
+          <a:prstGeom prst="rect">
+            <a:avLst/>
+          </a:prstGeom>
+          <a:noFill/>
+          <a:ln/>
+        </p:spPr>
+        <p:txBody>
+          <a:bodyPr wrap="square" lIns="0" tIns="0" rIns="0" bIns="0" rtlCol="0" anchor="ctr"/>
           <a:lstStyle/>
           <a:p>
             <a:pPr algn="ctr" indent="0" marL="0">
               <a:buNone/>
             </a:pPr>
             <a:r>
-              <a:rPr lang="en-US" sz="1300" b="1" dirty="0">
+              <a:rPr lang="en-US" sz="1200" b="1" dirty="0">
                 <a:solidFill>
                   <a:srgbClr val="FFFFFF"/>
                 </a:solidFill>
@@ -2747,46 +2744,7 @@
               </a:rPr>
               <a:t>KJV</a:t>
             </a:r>
-            <a:endParaRPr lang="en-US" sz="1300" dirty="0"/>
-          </a:p>
-        </p:txBody>
-      </p:sp>
-      <p:sp>
-        <p:nvSpPr>
-          <p:cNvPr id="11" name="Text 9"/>
-          <p:cNvSpPr/>
-          <p:nvPr/>
-        </p:nvSpPr>
-        <p:spPr>
-          <a:xfrm>
-            <a:off x="4160520" y="2468880"/>
-            <a:ext cx="3200400" cy="2011680"/>
-          </a:xfrm>
-          <a:prstGeom prst="rect">
-            <a:avLst/>
-          </a:prstGeom>
-          <a:noFill/>
-          <a:ln/>
-        </p:spPr>
-        <p:txBody>
-          <a:bodyPr wrap="square" rtlCol="0" anchor="ctr"/>
-          <a:lstStyle/>
-          <a:p>
-            <a:pPr indent="0" marL="0">
-              <a:buNone/>
-            </a:pPr>
-            <a:r>
-              <a:rPr lang="en-US" sz="1100" dirty="0">
-                <a:solidFill>
-                  <a:srgbClr val="666666"/>
-                </a:solidFill>
-                <a:latin typeface="Arial" pitchFamily="34" charset="0"/>
-                <a:ea typeface="Arial" pitchFamily="34" charset="-122"/>
-                <a:cs typeface="Arial" pitchFamily="34" charset="-120"/>
-              </a:rPr>
-              <a:t>¹ In the beginning God created the heaven and the earth. ² And the earth was without form, and void; and darkness was upon the face of the deep...</a:t>
-            </a:r>
-            <a:endParaRPr lang="en-US" sz="1100" dirty="0"/>
+            <a:endParaRPr lang="en-US" sz="1200" dirty="0"/>
           </a:p>
         </p:txBody>
       </p:sp>
@@ -2798,8 +2756,8 @@
         </p:nvSpPr>
         <p:spPr>
           <a:xfrm>
-            <a:off x="7772400" y="2011680"/>
-            <a:ext cx="4114800" cy="2560320"/>
+            <a:off x="5852160" y="1508760"/>
+            <a:ext cx="2651760" cy="3291840"/>
           </a:xfrm>
           <a:prstGeom prst="rect">
             <a:avLst/>
@@ -2807,9 +2765,9 @@
           <a:solidFill>
             <a:srgbClr val="FFFFFF"/>
           </a:solidFill>
-          <a:ln w="25400">
+          <a:ln w="12700">
             <a:solidFill>
-              <a:srgbClr val="C9A84C"/>
+              <a:srgbClr val="CCCCCC"/>
             </a:solidFill>
             <a:prstDash val="solid"/>
           </a:ln>
@@ -2817,14 +2775,14 @@
       </p:sp>
       <p:sp>
         <p:nvSpPr>
-          <p:cNvPr id="13" name="Text 11"/>
-          <p:cNvSpPr/>
-          <p:nvPr/>
-        </p:nvSpPr>
-        <p:spPr>
-          <a:xfrm>
-            <a:off x="7772400" y="2011680"/>
-            <a:ext cx="4114800" cy="365760"/>
+          <p:cNvPr id="13" name="Shape 11"/>
+          <p:cNvSpPr/>
+          <p:nvPr/>
+        </p:nvSpPr>
+        <p:spPr>
+          <a:xfrm>
+            <a:off x="5852160" y="1508760"/>
+            <a:ext cx="2651760" cy="320040"/>
           </a:xfrm>
           <a:prstGeom prst="rect">
             <a:avLst/>
@@ -2834,38 +2792,95 @@
           </a:solidFill>
           <a:ln/>
         </p:spPr>
+      </p:sp>
+      <p:sp>
+        <p:nvSpPr>
+          <p:cNvPr id="14" name="Text 12"/>
+          <p:cNvSpPr/>
+          <p:nvPr/>
+        </p:nvSpPr>
+        <p:spPr>
+          <a:xfrm>
+            <a:off x="5852160" y="1508760"/>
+            <a:ext cx="2651760" cy="320040"/>
+          </a:xfrm>
+          <a:prstGeom prst="rect">
+            <a:avLst/>
+          </a:prstGeom>
+          <a:noFill/>
+          <a:ln/>
+        </p:spPr>
+        <p:txBody>
+          <a:bodyPr wrap="square" lIns="0" tIns="0" rIns="0" bIns="0" rtlCol="0" anchor="ctr"/>
+          <a:lstStyle/>
+          <a:p>
+            <a:pPr algn="ctr" indent="0" marL="0">
+              <a:buNone/>
+            </a:pPr>
+            <a:r>
+              <a:rPr lang="en-US" sz="1200" b="1" dirty="0">
+                <a:solidFill>
+                  <a:srgbClr val="FFFFFF"/>
+                </a:solidFill>
+                <a:latin typeface="Arial" pitchFamily="34" charset="0"/>
+                <a:ea typeface="Arial" pitchFamily="34" charset="-122"/>
+                <a:cs typeface="Arial" pitchFamily="34" charset="-120"/>
+              </a:rPr>
+              <a:t>Commentary</a:t>
+            </a:r>
+            <a:endParaRPr lang="en-US" sz="1200" dirty="0"/>
+          </a:p>
+        </p:txBody>
+      </p:sp>
+      <p:sp>
+        <p:nvSpPr>
+          <p:cNvPr id="15" name="Text 13"/>
+          <p:cNvSpPr/>
+          <p:nvPr/>
+        </p:nvSpPr>
+        <p:spPr>
+          <a:xfrm>
+            <a:off x="365760" y="1920240"/>
+            <a:ext cx="2468880" cy="2743200"/>
+          </a:xfrm>
+          <a:prstGeom prst="rect">
+            <a:avLst/>
+          </a:prstGeom>
+          <a:noFill/>
+          <a:ln/>
+        </p:spPr>
         <p:txBody>
           <a:bodyPr wrap="square" rtlCol="0" anchor="ctr"/>
           <a:lstStyle/>
           <a:p>
-            <a:pPr algn="ctr" indent="0" marL="0">
-              <a:buNone/>
-            </a:pPr>
-            <a:r>
-              <a:rPr lang="en-US" sz="1300" b="1" dirty="0">
-                <a:solidFill>
-                  <a:srgbClr val="FFFFFF"/>
-                </a:solidFill>
-                <a:latin typeface="Arial" pitchFamily="34" charset="0"/>
-                <a:ea typeface="Arial" pitchFamily="34" charset="-122"/>
-                <a:cs typeface="Arial" pitchFamily="34" charset="-120"/>
-              </a:rPr>
-              <a:t>Commentary</a:t>
-            </a:r>
-            <a:endParaRPr lang="en-US" sz="1300" dirty="0"/>
-          </a:p>
-        </p:txBody>
-      </p:sp>
-      <p:sp>
-        <p:nvSpPr>
-          <p:cNvPr id="14" name="Text 12"/>
-          <p:cNvSpPr/>
-          <p:nvPr/>
-        </p:nvSpPr>
-        <p:spPr>
-          <a:xfrm>
-            <a:off x="7909560" y="2468880"/>
-            <a:ext cx="3840480" cy="2011680"/>
+            <a:pPr indent="0" marL="0">
+              <a:buNone/>
+            </a:pPr>
+            <a:r>
+              <a:rPr lang="en-US" sz="1000" dirty="0">
+                <a:solidFill>
+                  <a:srgbClr val="666666"/>
+                </a:solidFill>
+                <a:latin typeface="Arial" pitchFamily="34" charset="0"/>
+                <a:ea typeface="Arial" pitchFamily="34" charset="-122"/>
+                <a:cs typeface="Arial" pitchFamily="34" charset="-120"/>
+              </a:rPr>
+              <a:t>¹ In the beginning God created the heavens and the earth. ² Now the earth was formless and empty...</a:t>
+            </a:r>
+            <a:endParaRPr lang="en-US" sz="1000" dirty="0"/>
+          </a:p>
+        </p:txBody>
+      </p:sp>
+      <p:sp>
+        <p:nvSpPr>
+          <p:cNvPr id="16" name="Text 14"/>
+          <p:cNvSpPr/>
+          <p:nvPr/>
+        </p:nvSpPr>
+        <p:spPr>
+          <a:xfrm>
+            <a:off x="3154680" y="1920240"/>
+            <a:ext cx="2468880" cy="2743200"/>
           </a:xfrm>
           <a:prstGeom prst="rect">
             <a:avLst/>
@@ -2881,7 +2896,7 @@
               <a:buNone/>
             </a:pPr>
             <a:r>
-              <a:rPr lang="en-US" sz="1100" dirty="0">
+              <a:rPr lang="en-US" sz="1000" dirty="0">
                 <a:solidFill>
                   <a:srgbClr val="666666"/>
                 </a:solidFill>
@@ -2889,50 +2904,48 @@
                 <a:ea typeface="Arial" pitchFamily="34" charset="-122"/>
                 <a:cs typeface="Arial" pitchFamily="34" charset="-120"/>
               </a:rPr>
-              <a:t>The Hebrew בְּרֵאשִׁית (bereshit) opens without a definite article, suggesting the absolute beginning of creation. See also John 1:1 →</a:t>
-            </a:r>
-            <a:endParaRPr lang="en-US" sz="1100" dirty="0"/>
-          </a:p>
-        </p:txBody>
-      </p:sp>
-      <p:sp>
-        <p:nvSpPr>
-          <p:cNvPr id="15" name="Text 13"/>
-          <p:cNvSpPr/>
-          <p:nvPr/>
-        </p:nvSpPr>
-        <p:spPr>
-          <a:xfrm>
-            <a:off x="4572000" y="4709160"/>
-            <a:ext cx="3017520" cy="320040"/>
-          </a:xfrm>
-          <a:prstGeom prst="rect">
-            <a:avLst/>
-          </a:prstGeom>
-          <a:solidFill>
-            <a:srgbClr val="1A3A5C"/>
-          </a:solidFill>
+              <a:t>¹ In the beginning God created the heaven and the earth. ² And the earth was without form, and void...</a:t>
+            </a:r>
+            <a:endParaRPr lang="en-US" sz="1000" dirty="0"/>
+          </a:p>
+        </p:txBody>
+      </p:sp>
+      <p:sp>
+        <p:nvSpPr>
+          <p:cNvPr id="17" name="Text 15"/>
+          <p:cNvSpPr/>
+          <p:nvPr/>
+        </p:nvSpPr>
+        <p:spPr>
+          <a:xfrm>
+            <a:off x="5943600" y="1920240"/>
+            <a:ext cx="2468880" cy="2743200"/>
+          </a:xfrm>
+          <a:prstGeom prst="rect">
+            <a:avLst/>
+          </a:prstGeom>
+          <a:noFill/>
           <a:ln/>
         </p:spPr>
         <p:txBody>
           <a:bodyPr wrap="square" rtlCol="0" anchor="ctr"/>
           <a:lstStyle/>
           <a:p>
-            <a:pPr algn="ctr" indent="0" marL="0">
-              <a:buNone/>
-            </a:pPr>
-            <a:r>
-              <a:rPr lang="en-US" sz="1300" b="1" dirty="0">
-                <a:solidFill>
-                  <a:srgbClr val="FFFFFF"/>
-                </a:solidFill>
-                <a:latin typeface="Arial" pitchFamily="34" charset="0"/>
-                <a:ea typeface="Arial" pitchFamily="34" charset="-122"/>
-                <a:cs typeface="Arial" pitchFamily="34" charset="-120"/>
-              </a:rPr>
-              <a:t>+ Add Column</a:t>
-            </a:r>
-            <a:endParaRPr lang="en-US" sz="1300" dirty="0"/>
+            <a:pPr indent="0" marL="0">
+              <a:buNone/>
+            </a:pPr>
+            <a:r>
+              <a:rPr lang="en-US" sz="1000" dirty="0">
+                <a:solidFill>
+                  <a:srgbClr val="666666"/>
+                </a:solidFill>
+                <a:latin typeface="Arial" pitchFamily="34" charset="0"/>
+                <a:ea typeface="Arial" pitchFamily="34" charset="-122"/>
+                <a:cs typeface="Arial" pitchFamily="34" charset="-120"/>
+              </a:rPr>
+              <a:t>The Hebrew בְּרֵאשִׁית (bereshit) opens without a definite article, suggesting the absolute beginning. See also John 1:1 →</a:t>
+            </a:r>
+            <a:endParaRPr lang="en-US" sz="1000" dirty="0"/>
           </a:p>
         </p:txBody>
       </p:sp>
@@ -2977,7 +2990,7 @@
         <p:spPr>
           <a:xfrm>
             <a:off x="0" y="0"/>
-            <a:ext cx="12161520" cy="822960"/>
+            <a:ext cx="9144000" cy="685800"/>
           </a:xfrm>
           <a:prstGeom prst="rect">
             <a:avLst/>
@@ -2996,8 +3009,8 @@
         </p:nvSpPr>
         <p:spPr>
           <a:xfrm>
-            <a:off x="0" y="822960"/>
-            <a:ext cx="12161520" cy="54864"/>
+            <a:off x="0" y="685800"/>
+            <a:ext cx="9144000" cy="45720"/>
           </a:xfrm>
           <a:prstGeom prst="rect">
             <a:avLst/>
@@ -3016,8 +3029,8 @@
         </p:nvSpPr>
         <p:spPr>
           <a:xfrm>
-            <a:off x="365760" y="45720"/>
-            <a:ext cx="11430000" cy="731520"/>
+            <a:off x="274320" y="45720"/>
+            <a:ext cx="8595360" cy="594360"/>
           </a:xfrm>
           <a:prstGeom prst="rect">
             <a:avLst/>
@@ -3033,7 +3046,7 @@
               <a:buNone/>
             </a:pPr>
             <a:r>
-              <a:rPr lang="en-US" sz="2400" b="1" dirty="0">
+              <a:rPr lang="en-US" sz="2200" b="1" dirty="0">
                 <a:solidFill>
                   <a:srgbClr val="FFFFFF"/>
                 </a:solidFill>
@@ -3043,7 +3056,7 @@
               </a:rPr>
               <a:t>Progress — What Has Been Built</a:t>
             </a:r>
-            <a:endParaRPr lang="en-US" sz="2400" dirty="0"/>
+            <a:endParaRPr lang="en-US" sz="2200" dirty="0"/>
           </a:p>
         </p:txBody>
       </p:sp>
@@ -3055,8 +3068,8 @@
         </p:nvSpPr>
         <p:spPr>
           <a:xfrm>
-            <a:off x="365760" y="960120"/>
-            <a:ext cx="5303520" cy="320040"/>
+            <a:off x="274320" y="822960"/>
+            <a:ext cx="3931920" cy="274320"/>
           </a:xfrm>
           <a:prstGeom prst="rect">
             <a:avLst/>
@@ -3072,7 +3085,7 @@
               <a:buNone/>
             </a:pPr>
             <a:r>
-              <a:rPr lang="en-US" sz="1500" b="1" dirty="0">
+              <a:rPr lang="en-US" sz="1400" b="1" dirty="0">
                 <a:solidFill>
                   <a:srgbClr val="1A3A5C"/>
                 </a:solidFill>
@@ -3082,7 +3095,7 @@
               </a:rPr>
               <a:t>Data &amp; Ingestion</a:t>
             </a:r>
-            <a:endParaRPr lang="en-US" sz="1500" dirty="0"/>
+            <a:endParaRPr lang="en-US" sz="1400" dirty="0"/>
           </a:p>
         </p:txBody>
       </p:sp>
@@ -3094,8 +3107,8 @@
         </p:nvSpPr>
         <p:spPr>
           <a:xfrm>
-            <a:off x="365760" y="1325880"/>
-            <a:ext cx="5029200" cy="292608"/>
+            <a:off x="274320" y="1143000"/>
+            <a:ext cx="3931920" cy="274320"/>
           </a:xfrm>
           <a:prstGeom prst="rect">
             <a:avLst/>
@@ -3111,7 +3124,7 @@
               <a:buNone/>
             </a:pPr>
             <a:r>
-              <a:rPr lang="en-US" sz="1300" dirty="0">
+              <a:rPr lang="en-US" sz="1200" dirty="0">
                 <a:solidFill>
                   <a:srgbClr val="1A3A5C"/>
                 </a:solidFill>
@@ -3121,7 +3134,7 @@
               </a:rPr>
               <a:t>✅  NIV 2011 — 30,752 verses</a:t>
             </a:r>
-            <a:endParaRPr lang="en-US" sz="1300" dirty="0"/>
+            <a:endParaRPr lang="en-US" sz="1200" dirty="0"/>
           </a:p>
         </p:txBody>
       </p:sp>
@@ -3133,8 +3146,8 @@
         </p:nvSpPr>
         <p:spPr>
           <a:xfrm>
-            <a:off x="365760" y="1645920"/>
-            <a:ext cx="5029200" cy="292608"/>
+            <a:off x="274320" y="1435608"/>
+            <a:ext cx="3931920" cy="274320"/>
           </a:xfrm>
           <a:prstGeom prst="rect">
             <a:avLst/>
@@ -3150,7 +3163,7 @@
               <a:buNone/>
             </a:pPr>
             <a:r>
-              <a:rPr lang="en-US" sz="1300" dirty="0">
+              <a:rPr lang="en-US" sz="1200" dirty="0">
                 <a:solidFill>
                   <a:srgbClr val="1A3A5C"/>
                 </a:solidFill>
@@ -3160,7 +3173,7 @@
               </a:rPr>
               <a:t>✅  KJV 1611 — 36,820 verses (inc. Apocrypha)</a:t>
             </a:r>
-            <a:endParaRPr lang="en-US" sz="1300" dirty="0"/>
+            <a:endParaRPr lang="en-US" sz="1200" dirty="0"/>
           </a:p>
         </p:txBody>
       </p:sp>
@@ -3172,8 +3185,8 @@
         </p:nvSpPr>
         <p:spPr>
           <a:xfrm>
-            <a:off x="365760" y="1965960"/>
-            <a:ext cx="5029200" cy="292608"/>
+            <a:off x="274320" y="1728216"/>
+            <a:ext cx="3931920" cy="274320"/>
           </a:xfrm>
           <a:prstGeom prst="rect">
             <a:avLst/>
@@ -3189,7 +3202,7 @@
               <a:buNone/>
             </a:pPr>
             <a:r>
-              <a:rPr lang="en-US" sz="1300" dirty="0">
+              <a:rPr lang="en-US" sz="1200" dirty="0">
                 <a:solidFill>
                   <a:srgbClr val="1A3A5C"/>
                 </a:solidFill>
@@ -3199,7 +3212,7 @@
               </a:rPr>
               <a:t>✅  ASV 1901 — 31,102 verses</a:t>
             </a:r>
-            <a:endParaRPr lang="en-US" sz="1300" dirty="0"/>
+            <a:endParaRPr lang="en-US" sz="1200" dirty="0"/>
           </a:p>
         </p:txBody>
       </p:sp>
@@ -3211,8 +3224,8 @@
         </p:nvSpPr>
         <p:spPr>
           <a:xfrm>
-            <a:off x="365760" y="2286000"/>
-            <a:ext cx="5029200" cy="292608"/>
+            <a:off x="274320" y="2020824"/>
+            <a:ext cx="3931920" cy="274320"/>
           </a:xfrm>
           <a:prstGeom prst="rect">
             <a:avLst/>
@@ -3228,7 +3241,7 @@
               <a:buNone/>
             </a:pPr>
             <a:r>
-              <a:rPr lang="en-US" sz="1300" dirty="0">
+              <a:rPr lang="en-US" sz="1200" dirty="0">
                 <a:solidFill>
                   <a:srgbClr val="1A3A5C"/>
                 </a:solidFill>
@@ -3238,7 +3251,7 @@
               </a:rPr>
               <a:t>✅  World English Bible</a:t>
             </a:r>
-            <a:endParaRPr lang="en-US" sz="1300" dirty="0"/>
+            <a:endParaRPr lang="en-US" sz="1200" dirty="0"/>
           </a:p>
         </p:txBody>
       </p:sp>
@@ -3250,8 +3263,8 @@
         </p:nvSpPr>
         <p:spPr>
           <a:xfrm>
-            <a:off x="365760" y="2606040"/>
-            <a:ext cx="5029200" cy="292608"/>
+            <a:off x="274320" y="2313432"/>
+            <a:ext cx="3931920" cy="274320"/>
           </a:xfrm>
           <a:prstGeom prst="rect">
             <a:avLst/>
@@ -3267,7 +3280,7 @@
               <a:buNone/>
             </a:pPr>
             <a:r>
-              <a:rPr lang="en-US" sz="1300" dirty="0">
+              <a:rPr lang="en-US" sz="1200" dirty="0">
                 <a:solidFill>
                   <a:srgbClr val="1A3A5C"/>
                 </a:solidFill>
@@ -3277,7 +3290,7 @@
               </a:rPr>
               <a:t>✅  Douay-Rheims 1899 (Catholic)</a:t>
             </a:r>
-            <a:endParaRPr lang="en-US" sz="1300" dirty="0"/>
+            <a:endParaRPr lang="en-US" sz="1200" dirty="0"/>
           </a:p>
         </p:txBody>
       </p:sp>
@@ -3289,8 +3302,8 @@
         </p:nvSpPr>
         <p:spPr>
           <a:xfrm>
-            <a:off x="365760" y="2926080"/>
-            <a:ext cx="5029200" cy="292608"/>
+            <a:off x="274320" y="2606040"/>
+            <a:ext cx="3931920" cy="274320"/>
           </a:xfrm>
           <a:prstGeom prst="rect">
             <a:avLst/>
@@ -3306,7 +3319,7 @@
               <a:buNone/>
             </a:pPr>
             <a:r>
-              <a:rPr lang="en-US" sz="1300" dirty="0">
+              <a:rPr lang="en-US" sz="1200" dirty="0">
                 <a:solidFill>
                   <a:srgbClr val="1A3A5C"/>
                 </a:solidFill>
@@ -3316,7 +3329,7 @@
               </a:rPr>
               <a:t>✅  Reina Valera 1909 (Spanish)</a:t>
             </a:r>
-            <a:endParaRPr lang="en-US" sz="1300" dirty="0"/>
+            <a:endParaRPr lang="en-US" sz="1200" dirty="0"/>
           </a:p>
         </p:txBody>
       </p:sp>
@@ -3328,8 +3341,8 @@
         </p:nvSpPr>
         <p:spPr>
           <a:xfrm>
-            <a:off x="365760" y="3246120"/>
-            <a:ext cx="5029200" cy="292608"/>
+            <a:off x="274320" y="2898648"/>
+            <a:ext cx="3931920" cy="274320"/>
           </a:xfrm>
           <a:prstGeom prst="rect">
             <a:avLst/>
@@ -3345,7 +3358,7 @@
               <a:buNone/>
             </a:pPr>
             <a:r>
-              <a:rPr lang="en-US" sz="1300" dirty="0">
+              <a:rPr lang="en-US" sz="1200" dirty="0">
                 <a:solidFill>
                   <a:srgbClr val="1A3A5C"/>
                 </a:solidFill>
@@ -3355,7 +3368,7 @@
               </a:rPr>
               <a:t>⏳  NASB 2020, NBLA — pending</a:t>
             </a:r>
-            <a:endParaRPr lang="en-US" sz="1300" dirty="0"/>
+            <a:endParaRPr lang="en-US" sz="1200" dirty="0"/>
           </a:p>
         </p:txBody>
       </p:sp>
@@ -3367,8 +3380,8 @@
         </p:nvSpPr>
         <p:spPr>
           <a:xfrm>
-            <a:off x="365760" y="3566160"/>
-            <a:ext cx="5029200" cy="292608"/>
+            <a:off x="274320" y="3191256"/>
+            <a:ext cx="3931920" cy="274320"/>
           </a:xfrm>
           <a:prstGeom prst="rect">
             <a:avLst/>
@@ -3384,7 +3397,7 @@
               <a:buNone/>
             </a:pPr>
             <a:r>
-              <a:rPr lang="en-US" sz="1300" dirty="0">
+              <a:rPr lang="en-US" sz="1200" dirty="0">
                 <a:solidFill>
                   <a:srgbClr val="1A3A5C"/>
                 </a:solidFill>
@@ -3394,7 +3407,7 @@
               </a:rPr>
               <a:t>📋  Quran + Hadith — planned</a:t>
             </a:r>
-            <a:endParaRPr lang="en-US" sz="1300" dirty="0"/>
+            <a:endParaRPr lang="en-US" sz="1200" dirty="0"/>
           </a:p>
         </p:txBody>
       </p:sp>
@@ -3406,8 +3419,8 @@
         </p:nvSpPr>
         <p:spPr>
           <a:xfrm>
-            <a:off x="6080760" y="914400"/>
-            <a:ext cx="0" cy="3474720"/>
+            <a:off x="4572000" y="777240"/>
+            <a:ext cx="0" cy="3931920"/>
           </a:xfrm>
           <a:prstGeom prst="line">
             <a:avLst/>
@@ -3429,8 +3442,8 @@
         </p:nvSpPr>
         <p:spPr>
           <a:xfrm>
-            <a:off x="6309360" y="960120"/>
-            <a:ext cx="5486400" cy="320040"/>
+            <a:off x="4754880" y="822960"/>
+            <a:ext cx="3931920" cy="274320"/>
           </a:xfrm>
           <a:prstGeom prst="rect">
             <a:avLst/>
@@ -3446,7 +3459,7 @@
               <a:buNone/>
             </a:pPr>
             <a:r>
-              <a:rPr lang="en-US" sz="1500" b="1" dirty="0">
+              <a:rPr lang="en-US" sz="1400" b="1" dirty="0">
                 <a:solidFill>
                   <a:srgbClr val="1A3A5C"/>
                 </a:solidFill>
@@ -3456,7 +3469,7 @@
               </a:rPr>
               <a:t>Reader Application</a:t>
             </a:r>
-            <a:endParaRPr lang="en-US" sz="1500" dirty="0"/>
+            <a:endParaRPr lang="en-US" sz="1400" dirty="0"/>
           </a:p>
         </p:txBody>
       </p:sp>
@@ -3468,8 +3481,8 @@
         </p:nvSpPr>
         <p:spPr>
           <a:xfrm>
-            <a:off x="6309360" y="1325880"/>
-            <a:ext cx="5029200" cy="292608"/>
+            <a:off x="4754880" y="1143000"/>
+            <a:ext cx="3931920" cy="274320"/>
           </a:xfrm>
           <a:prstGeom prst="rect">
             <a:avLst/>
@@ -3485,7 +3498,7 @@
               <a:buNone/>
             </a:pPr>
             <a:r>
-              <a:rPr lang="en-US" sz="1300" dirty="0">
+              <a:rPr lang="en-US" sz="1200" dirty="0">
                 <a:solidFill>
                   <a:srgbClr val="1A3A5C"/>
                 </a:solidFill>
@@ -3495,7 +3508,7 @@
               </a:rPr>
               <a:t>✅  Multi-column reader (33vw per column)</a:t>
             </a:r>
-            <a:endParaRPr lang="en-US" sz="1300" dirty="0"/>
+            <a:endParaRPr lang="en-US" sz="1200" dirty="0"/>
           </a:p>
         </p:txBody>
       </p:sp>
@@ -3507,8 +3520,8 @@
         </p:nvSpPr>
         <p:spPr>
           <a:xfrm>
-            <a:off x="6309360" y="1645920"/>
-            <a:ext cx="5029200" cy="292608"/>
+            <a:off x="4754880" y="1435608"/>
+            <a:ext cx="3931920" cy="274320"/>
           </a:xfrm>
           <a:prstGeom prst="rect">
             <a:avLst/>
@@ -3524,7 +3537,7 @@
               <a:buNone/>
             </a:pPr>
             <a:r>
-              <a:rPr lang="en-US" sz="1300" dirty="0">
+              <a:rPr lang="en-US" sz="1200" dirty="0">
                 <a:solidFill>
                   <a:srgbClr val="1A3A5C"/>
                 </a:solidFill>
@@ -3532,9 +3545,9 @@
                 <a:ea typeface="Arial" pitchFamily="34" charset="-122"/>
                 <a:cs typeface="Arial" pitchFamily="34" charset="-120"/>
               </a:rPr>
-              <a:t>✅  Per-column source &amp; display mode selector</a:t>
-            </a:r>
-            <a:endParaRPr lang="en-US" sz="1300" dirty="0"/>
+              <a:t>✅  Per-column source &amp; display mode</a:t>
+            </a:r>
+            <a:endParaRPr lang="en-US" sz="1200" dirty="0"/>
           </a:p>
         </p:txBody>
       </p:sp>
@@ -3546,8 +3559,8 @@
         </p:nvSpPr>
         <p:spPr>
           <a:xfrm>
-            <a:off x="6309360" y="1965960"/>
-            <a:ext cx="5029200" cy="292608"/>
+            <a:off x="4754880" y="1728216"/>
+            <a:ext cx="3931920" cy="274320"/>
           </a:xfrm>
           <a:prstGeom prst="rect">
             <a:avLst/>
@@ -3563,7 +3576,7 @@
               <a:buNone/>
             </a:pPr>
             <a:r>
-              <a:rPr lang="en-US" sz="1300" dirty="0">
+              <a:rPr lang="en-US" sz="1200" dirty="0">
                 <a:solidFill>
                   <a:srgbClr val="1A3A5C"/>
                 </a:solidFill>
@@ -3573,7 +3586,7 @@
               </a:rPr>
               <a:t>✅  Column sync / unsync</a:t>
             </a:r>
-            <a:endParaRPr lang="en-US" sz="1300" dirty="0"/>
+            <a:endParaRPr lang="en-US" sz="1200" dirty="0"/>
           </a:p>
         </p:txBody>
       </p:sp>
@@ -3585,8 +3598,8 @@
         </p:nvSpPr>
         <p:spPr>
           <a:xfrm>
-            <a:off x="6309360" y="2286000"/>
-            <a:ext cx="5029200" cy="292608"/>
+            <a:off x="4754880" y="2020824"/>
+            <a:ext cx="3931920" cy="274320"/>
           </a:xfrm>
           <a:prstGeom prst="rect">
             <a:avLst/>
@@ -3602,7 +3615,7 @@
               <a:buNone/>
             </a:pPr>
             <a:r>
-              <a:rPr lang="en-US" sz="1300" dirty="0">
+              <a:rPr lang="en-US" sz="1200" dirty="0">
                 <a:solidFill>
                   <a:srgbClr val="1A3A5C"/>
                 </a:solidFill>
@@ -3612,7 +3625,7 @@
               </a:rPr>
               <a:t>✅  Original / Chapters / Verses / Titles modes</a:t>
             </a:r>
-            <a:endParaRPr lang="en-US" sz="1300" dirty="0"/>
+            <a:endParaRPr lang="en-US" sz="1200" dirty="0"/>
           </a:p>
         </p:txBody>
       </p:sp>
@@ -3624,8 +3637,8 @@
         </p:nvSpPr>
         <p:spPr>
           <a:xfrm>
-            <a:off x="6309360" y="2606040"/>
-            <a:ext cx="5029200" cy="292608"/>
+            <a:off x="4754880" y="2313432"/>
+            <a:ext cx="3931920" cy="274320"/>
           </a:xfrm>
           <a:prstGeom prst="rect">
             <a:avLst/>
@@ -3641,7 +3654,7 @@
               <a:buNone/>
             </a:pPr>
             <a:r>
-              <a:rPr lang="en-US" sz="1300" dirty="0">
+              <a:rPr lang="en-US" sz="1200" dirty="0">
                 <a:solidFill>
                   <a:srgbClr val="1A3A5C"/>
                 </a:solidFill>
@@ -3651,7 +3664,7 @@
               </a:rPr>
               <a:t>✅  Translation-independent verse anchors</a:t>
             </a:r>
-            <a:endParaRPr lang="en-US" sz="1300" dirty="0"/>
+            <a:endParaRPr lang="en-US" sz="1200" dirty="0"/>
           </a:p>
         </p:txBody>
       </p:sp>
@@ -3663,8 +3676,8 @@
         </p:nvSpPr>
         <p:spPr>
           <a:xfrm>
-            <a:off x="6309360" y="2926080"/>
-            <a:ext cx="5029200" cy="292608"/>
+            <a:off x="4754880" y="2606040"/>
+            <a:ext cx="3931920" cy="274320"/>
           </a:xfrm>
           <a:prstGeom prst="rect">
             <a:avLst/>
@@ -3680,7 +3693,7 @@
               <a:buNone/>
             </a:pPr>
             <a:r>
-              <a:rPr lang="en-US" sz="1300" dirty="0">
+              <a:rPr lang="en-US" sz="1200" dirty="0">
                 <a:solidFill>
                   <a:srgbClr val="1A3A5C"/>
                 </a:solidFill>
@@ -3688,9 +3701,9 @@
                 <a:ea typeface="Arial" pitchFamily="34" charset="-122"/>
                 <a:cs typeface="Arial" pitchFamily="34" charset="-120"/>
               </a:rPr>
-              <a:t>⏳  Continuous scroll (book-level)</a:t>
-            </a:r>
-            <a:endParaRPr lang="en-US" sz="1300" dirty="0"/>
+              <a:t>⏳  Continuous scroll (book-level DOM)</a:t>
+            </a:r>
+            <a:endParaRPr lang="en-US" sz="1200" dirty="0"/>
           </a:p>
         </p:txBody>
       </p:sp>
@@ -3702,8 +3715,8 @@
         </p:nvSpPr>
         <p:spPr>
           <a:xfrm>
-            <a:off x="6309360" y="3246120"/>
-            <a:ext cx="5029200" cy="292608"/>
+            <a:off x="4754880" y="2898648"/>
+            <a:ext cx="3931920" cy="274320"/>
           </a:xfrm>
           <a:prstGeom prst="rect">
             <a:avLst/>
@@ -3719,7 +3732,7 @@
               <a:buNone/>
             </a:pPr>
             <a:r>
-              <a:rPr lang="en-US" sz="1300" dirty="0">
+              <a:rPr lang="en-US" sz="1200" dirty="0">
                 <a:solidFill>
                   <a:srgbClr val="1A3A5C"/>
                 </a:solidFill>
@@ -3729,7 +3742,7 @@
               </a:rPr>
               <a:t>⏳  Commentary cross-reference links</a:t>
             </a:r>
-            <a:endParaRPr lang="en-US" sz="1300" dirty="0"/>
+            <a:endParaRPr lang="en-US" sz="1200" dirty="0"/>
           </a:p>
         </p:txBody>
       </p:sp>
@@ -3741,8 +3754,8 @@
         </p:nvSpPr>
         <p:spPr>
           <a:xfrm>
-            <a:off x="6309360" y="3566160"/>
-            <a:ext cx="5029200" cy="292608"/>
+            <a:off x="4754880" y="3191256"/>
+            <a:ext cx="3931920" cy="274320"/>
           </a:xfrm>
           <a:prstGeom prst="rect">
             <a:avLst/>
@@ -3758,7 +3771,7 @@
               <a:buNone/>
             </a:pPr>
             <a:r>
-              <a:rPr lang="en-US" sz="1300" dirty="0">
+              <a:rPr lang="en-US" sz="1200" dirty="0">
                 <a:solidFill>
                   <a:srgbClr val="1A3A5C"/>
                 </a:solidFill>
@@ -3768,7 +3781,7 @@
               </a:rPr>
               <a:t>📋  User login + personal notes</a:t>
             </a:r>
-            <a:endParaRPr lang="en-US" sz="1300" dirty="0"/>
+            <a:endParaRPr lang="en-US" sz="1200" dirty="0"/>
           </a:p>
         </p:txBody>
       </p:sp>
@@ -3780,8 +3793,8 @@
         </p:nvSpPr>
         <p:spPr>
           <a:xfrm>
-            <a:off x="365760" y="4480560"/>
-            <a:ext cx="11430000" cy="320040"/>
+            <a:off x="274320" y="4686300"/>
+            <a:ext cx="8595360" cy="274320"/>
           </a:xfrm>
           <a:prstGeom prst="rect">
             <a:avLst/>
@@ -3797,7 +3810,7 @@
               <a:buNone/>
             </a:pPr>
             <a:r>
-              <a:rPr lang="en-US" sz="1200" i="1" dirty="0">
+              <a:rPr lang="en-US" sz="1100" i="1" dirty="0">
                 <a:solidFill>
                   <a:srgbClr val="666666"/>
                 </a:solidFill>
@@ -3807,7 +3820,7 @@
               </a:rPr>
               <a:t>✅ Complete   ⏳ In progress   📋 Planned</a:t>
             </a:r>
-            <a:endParaRPr lang="en-US" sz="1200" dirty="0"/>
+            <a:endParaRPr lang="en-US" sz="1100" dirty="0"/>
           </a:p>
         </p:txBody>
       </p:sp>
@@ -3852,7 +3865,7 @@
         <p:spPr>
           <a:xfrm>
             <a:off x="0" y="0"/>
-            <a:ext cx="12161520" cy="822960"/>
+            <a:ext cx="9144000" cy="685800"/>
           </a:xfrm>
           <a:prstGeom prst="rect">
             <a:avLst/>
@@ -3871,8 +3884,8 @@
         </p:nvSpPr>
         <p:spPr>
           <a:xfrm>
-            <a:off x="0" y="822960"/>
-            <a:ext cx="12161520" cy="54864"/>
+            <a:off x="0" y="685800"/>
+            <a:ext cx="9144000" cy="45720"/>
           </a:xfrm>
           <a:prstGeom prst="rect">
             <a:avLst/>
@@ -3891,8 +3904,8 @@
         </p:nvSpPr>
         <p:spPr>
           <a:xfrm>
-            <a:off x="365760" y="45720"/>
-            <a:ext cx="11430000" cy="731520"/>
+            <a:off x="274320" y="45720"/>
+            <a:ext cx="8595360" cy="594360"/>
           </a:xfrm>
           <a:prstGeom prst="rect">
             <a:avLst/>
@@ -3908,7 +3921,7 @@
               <a:buNone/>
             </a:pPr>
             <a:r>
-              <a:rPr lang="en-US" sz="2400" b="1" dirty="0">
+              <a:rPr lang="en-US" sz="2200" b="1" dirty="0">
                 <a:solidFill>
                   <a:srgbClr val="FFFFFF"/>
                 </a:solidFill>
@@ -3918,7 +3931,7 @@
               </a:rPr>
               <a:t>Supported Traditions &amp; Languages</a:t>
             </a:r>
-            <a:endParaRPr lang="en-US" sz="2400" dirty="0"/>
+            <a:endParaRPr lang="en-US" sz="2200" dirty="0"/>
           </a:p>
         </p:txBody>
       </p:sp>
@@ -3930,8 +3943,8 @@
         </p:nvSpPr>
         <p:spPr>
           <a:xfrm>
-            <a:off x="274320" y="1005840"/>
-            <a:ext cx="3566160" cy="3291840"/>
+            <a:off x="274320" y="822960"/>
+            <a:ext cx="2804160" cy="4023360"/>
           </a:xfrm>
           <a:prstGeom prst="rect">
             <a:avLst/>
@@ -3946,7 +3959,7 @@
             <a:prstDash val="solid"/>
           </a:ln>
           <a:effectLst>
-            <a:outerShdw sx="100000" sy="100000" kx="0" ky="0" algn="bl" rotWithShape="0" blurRad="50800" dist="25400" dir="2700000">
+            <a:outerShdw sx="100000" sy="100000" kx="0" ky="0" algn="bl" rotWithShape="0" blurRad="38100" dist="25400" dir="2700000">
               <a:srgbClr val="CCCCCC">
                 <a:alpha val="30000"/>
               </a:srgbClr>
@@ -3962,8 +3975,8 @@
         </p:nvSpPr>
         <p:spPr>
           <a:xfrm>
-            <a:off x="274320" y="1005840"/>
-            <a:ext cx="3566160" cy="54864"/>
+            <a:off x="274320" y="822960"/>
+            <a:ext cx="2804160" cy="45720"/>
           </a:xfrm>
           <a:prstGeom prst="rect">
             <a:avLst/>
@@ -3982,8 +3995,8 @@
         </p:nvSpPr>
         <p:spPr>
           <a:xfrm>
-            <a:off x="274320" y="1143000"/>
-            <a:ext cx="3566160" cy="457200"/>
+            <a:off x="274320" y="914400"/>
+            <a:ext cx="2804160" cy="411480"/>
           </a:xfrm>
           <a:prstGeom prst="rect">
             <a:avLst/>
@@ -3999,14 +4012,14 @@
               <a:buNone/>
             </a:pPr>
             <a:r>
-              <a:rPr lang="en-US" sz="2600" dirty="0">
+              <a:rPr lang="en-US" sz="2200" dirty="0">
                 <a:solidFill>
                   <a:srgbClr val="000000"/>
                 </a:solidFill>
               </a:rPr>
               <a:t>✝️</a:t>
             </a:r>
-            <a:endParaRPr lang="en-US" sz="2600" dirty="0"/>
+            <a:endParaRPr lang="en-US" sz="2200" dirty="0"/>
           </a:p>
         </p:txBody>
       </p:sp>
@@ -4018,8 +4031,8 @@
         </p:nvSpPr>
         <p:spPr>
           <a:xfrm>
-            <a:off x="411480" y="1600200"/>
-            <a:ext cx="3291840" cy="320040"/>
+            <a:off x="365760" y="1325880"/>
+            <a:ext cx="2621280" cy="274320"/>
           </a:xfrm>
           <a:prstGeom prst="rect">
             <a:avLst/>
@@ -4035,7 +4048,7 @@
               <a:buNone/>
             </a:pPr>
             <a:r>
-              <a:rPr lang="en-US" sz="1400" b="1" dirty="0">
+              <a:rPr lang="en-US" sz="1300" b="1" dirty="0">
                 <a:solidFill>
                   <a:srgbClr val="1A3A5C"/>
                 </a:solidFill>
@@ -4045,7 +4058,7 @@
               </a:rPr>
               <a:t>Bible</a:t>
             </a:r>
-            <a:endParaRPr lang="en-US" sz="1400" dirty="0"/>
+            <a:endParaRPr lang="en-US" sz="1300" dirty="0"/>
           </a:p>
         </p:txBody>
       </p:sp>
@@ -4057,8 +4070,8 @@
         </p:nvSpPr>
         <p:spPr>
           <a:xfrm>
-            <a:off x="411480" y="1920240"/>
-            <a:ext cx="3291840" cy="2240280"/>
+            <a:off x="365760" y="1600200"/>
+            <a:ext cx="2621280" cy="3154680"/>
           </a:xfrm>
           <a:prstGeom prst="rect">
             <a:avLst/>
@@ -4074,7 +4087,7 @@
               <a:buNone/>
             </a:pPr>
             <a:r>
-              <a:rPr lang="en-US" sz="1100" dirty="0">
+              <a:rPr lang="en-US" sz="1000" dirty="0">
                 <a:solidFill>
                   <a:srgbClr val="666666"/>
                 </a:solidFill>
@@ -4084,14 +4097,14 @@
               </a:rPr>
               <a:t>6 translations ingested</a:t>
             </a:r>
-            <a:endParaRPr lang="en-US" sz="1100" dirty="0"/>
+            <a:endParaRPr lang="en-US" sz="1000" dirty="0"/>
           </a:p>
           <a:p>
             <a:pPr algn="ctr" indent="0" marL="0">
               <a:buNone/>
             </a:pPr>
             <a:r>
-              <a:rPr lang="en-US" sz="1100" dirty="0">
+              <a:rPr lang="en-US" sz="1000" dirty="0">
                 <a:solidFill>
                   <a:srgbClr val="666666"/>
                 </a:solidFill>
@@ -4101,20 +4114,20 @@
               </a:rPr>
               <a:t>NIV · KJV · ASV · WEB · DRA · RVR09</a:t>
             </a:r>
-            <a:endParaRPr lang="en-US" sz="1100" dirty="0"/>
+            <a:endParaRPr lang="en-US" sz="1000" dirty="0"/>
           </a:p>
           <a:p>
             <a:pPr algn="ctr" indent="0" marL="0">
               <a:buNone/>
             </a:pPr>
-            <a:endParaRPr lang="en-US" sz="1100" dirty="0"/>
+            <a:endParaRPr lang="en-US" sz="1000" dirty="0"/>
           </a:p>
           <a:p>
             <a:pPr algn="ctr" indent="0" marL="0">
               <a:buNone/>
             </a:pPr>
             <a:r>
-              <a:rPr lang="en-US" sz="1100" dirty="0">
+              <a:rPr lang="en-US" sz="1000" dirty="0">
                 <a:solidFill>
                   <a:srgbClr val="666666"/>
                 </a:solidFill>
@@ -4122,16 +4135,16 @@
                 <a:ea typeface="Arial" pitchFamily="34" charset="-122"/>
                 <a:cs typeface="Arial" pitchFamily="34" charset="-120"/>
               </a:rPr>
-              <a:t>200+ translations in local source</a:t>
-            </a:r>
-            <a:endParaRPr lang="en-US" sz="1100" dirty="0"/>
+              <a:t>200+ in local source</a:t>
+            </a:r>
+            <a:endParaRPr lang="en-US" sz="1000" dirty="0"/>
           </a:p>
           <a:p>
             <a:pPr algn="ctr" indent="0" marL="0">
               <a:buNone/>
             </a:pPr>
             <a:r>
-              <a:rPr lang="en-US" sz="1100" dirty="0">
+              <a:rPr lang="en-US" sz="1000" dirty="0">
                 <a:solidFill>
                   <a:srgbClr val="666666"/>
                 </a:solidFill>
@@ -4139,9 +4152,9 @@
                 <a:ea typeface="Arial" pitchFamily="34" charset="-122"/>
                 <a:cs typeface="Arial" pitchFamily="34" charset="-120"/>
               </a:rPr>
-              <a:t>English · Spanish · German · Greek · Hebrew · Finnish · Arabic and more</a:t>
-            </a:r>
-            <a:endParaRPr lang="en-US" sz="1100" dirty="0"/>
+              <a:t>English · Spanish · German · Greek · Hebrew · Arabic and more</a:t>
+            </a:r>
+            <a:endParaRPr lang="en-US" sz="1000" dirty="0"/>
           </a:p>
         </p:txBody>
       </p:sp>
@@ -4153,8 +4166,8 @@
         </p:nvSpPr>
         <p:spPr>
           <a:xfrm>
-            <a:off x="4114800" y="1005840"/>
-            <a:ext cx="3566160" cy="3291840"/>
+            <a:off x="3169920" y="822960"/>
+            <a:ext cx="2804160" cy="4023360"/>
           </a:xfrm>
           <a:prstGeom prst="rect">
             <a:avLst/>
@@ -4169,7 +4182,7 @@
             <a:prstDash val="solid"/>
           </a:ln>
           <a:effectLst>
-            <a:outerShdw sx="100000" sy="100000" kx="0" ky="0" algn="bl" rotWithShape="0" blurRad="50800" dist="25400" dir="2700000">
+            <a:outerShdw sx="100000" sy="100000" kx="0" ky="0" algn="bl" rotWithShape="0" blurRad="38100" dist="25400" dir="2700000">
               <a:srgbClr val="CCCCCC">
                 <a:alpha val="30000"/>
               </a:srgbClr>
@@ -4185,8 +4198,8 @@
         </p:nvSpPr>
         <p:spPr>
           <a:xfrm>
-            <a:off x="4114800" y="1005840"/>
-            <a:ext cx="3566160" cy="54864"/>
+            <a:off x="3169920" y="822960"/>
+            <a:ext cx="2804160" cy="45720"/>
           </a:xfrm>
           <a:prstGeom prst="rect">
             <a:avLst/>
@@ -4205,8 +4218,8 @@
         </p:nvSpPr>
         <p:spPr>
           <a:xfrm>
-            <a:off x="4114800" y="1143000"/>
-            <a:ext cx="3566160" cy="457200"/>
+            <a:off x="3169920" y="914400"/>
+            <a:ext cx="2804160" cy="411480"/>
           </a:xfrm>
           <a:prstGeom prst="rect">
             <a:avLst/>
@@ -4222,14 +4235,14 @@
               <a:buNone/>
             </a:pPr>
             <a:r>
-              <a:rPr lang="en-US" sz="2600" dirty="0">
+              <a:rPr lang="en-US" sz="2200" dirty="0">
                 <a:solidFill>
                   <a:srgbClr val="000000"/>
                 </a:solidFill>
               </a:rPr>
               <a:t>☪️</a:t>
             </a:r>
-            <a:endParaRPr lang="en-US" sz="2600" dirty="0"/>
+            <a:endParaRPr lang="en-US" sz="2200" dirty="0"/>
           </a:p>
         </p:txBody>
       </p:sp>
@@ -4241,8 +4254,8 @@
         </p:nvSpPr>
         <p:spPr>
           <a:xfrm>
-            <a:off x="4251960" y="1600200"/>
-            <a:ext cx="3291840" cy="320040"/>
+            <a:off x="3261360" y="1325880"/>
+            <a:ext cx="2621280" cy="274320"/>
           </a:xfrm>
           <a:prstGeom prst="rect">
             <a:avLst/>
@@ -4258,7 +4271,7 @@
               <a:buNone/>
             </a:pPr>
             <a:r>
-              <a:rPr lang="en-US" sz="1400" b="1" dirty="0">
+              <a:rPr lang="en-US" sz="1300" b="1" dirty="0">
                 <a:solidFill>
                   <a:srgbClr val="1A3A5C"/>
                 </a:solidFill>
@@ -4268,7 +4281,7 @@
               </a:rPr>
               <a:t>Quran &amp; Hadith</a:t>
             </a:r>
-            <a:endParaRPr lang="en-US" sz="1400" dirty="0"/>
+            <a:endParaRPr lang="en-US" sz="1300" dirty="0"/>
           </a:p>
         </p:txBody>
       </p:sp>
@@ -4280,8 +4293,8 @@
         </p:nvSpPr>
         <p:spPr>
           <a:xfrm>
-            <a:off x="4251960" y="1920240"/>
-            <a:ext cx="3291840" cy="2240280"/>
+            <a:off x="3261360" y="1600200"/>
+            <a:ext cx="2621280" cy="3154680"/>
           </a:xfrm>
           <a:prstGeom prst="rect">
             <a:avLst/>
@@ -4297,7 +4310,7 @@
               <a:buNone/>
             </a:pPr>
             <a:r>
-              <a:rPr lang="en-US" sz="1100" dirty="0">
+              <a:rPr lang="en-US" sz="1000" dirty="0">
                 <a:solidFill>
                   <a:srgbClr val="666666"/>
                 </a:solidFill>
@@ -4305,22 +4318,22 @@
                 <a:ea typeface="Arial" pitchFamily="34" charset="-122"/>
                 <a:cs typeface="Arial" pitchFamily="34" charset="-120"/>
               </a:rPr>
-              <a:t>Planned — Quran ingestion via fawazahmed0/quran-api</a:t>
-            </a:r>
-            <a:endParaRPr lang="en-US" sz="1100" dirty="0"/>
+              <a:t>Planned — fawazahmed0/quran-api</a:t>
+            </a:r>
+            <a:endParaRPr lang="en-US" sz="1000" dirty="0"/>
           </a:p>
           <a:p>
             <a:pPr algn="ctr" indent="0" marL="0">
               <a:buNone/>
             </a:pPr>
-            <a:endParaRPr lang="en-US" sz="1100" dirty="0"/>
+            <a:endParaRPr lang="en-US" sz="1000" dirty="0"/>
           </a:p>
           <a:p>
             <a:pPr algn="ctr" indent="0" marL="0">
               <a:buNone/>
             </a:pPr>
             <a:r>
-              <a:rPr lang="en-US" sz="1100" dirty="0">
+              <a:rPr lang="en-US" sz="1000" dirty="0">
                 <a:solidFill>
                   <a:srgbClr val="666666"/>
                 </a:solidFill>
@@ -4330,7 +4343,7 @@
               </a:rPr>
               <a:t>Hadith: Sahih al-Bukhari, Sahih Muslim, Sunan Abu Dawud, Tirmidhi, Ibn Majah, Nasai</a:t>
             </a:r>
-            <a:endParaRPr lang="en-US" sz="1100" dirty="0"/>
+            <a:endParaRPr lang="en-US" sz="1000" dirty="0"/>
           </a:p>
         </p:txBody>
       </p:sp>
@@ -4342,8 +4355,8 @@
         </p:nvSpPr>
         <p:spPr>
           <a:xfrm>
-            <a:off x="7955280" y="1005840"/>
-            <a:ext cx="3931920" cy="3291840"/>
+            <a:off x="6065520" y="822960"/>
+            <a:ext cx="2804160" cy="4023360"/>
           </a:xfrm>
           <a:prstGeom prst="rect">
             <a:avLst/>
@@ -4358,7 +4371,7 @@
             <a:prstDash val="solid"/>
           </a:ln>
           <a:effectLst>
-            <a:outerShdw sx="100000" sy="100000" kx="0" ky="0" algn="bl" rotWithShape="0" blurRad="50800" dist="25400" dir="2700000">
+            <a:outerShdw sx="100000" sy="100000" kx="0" ky="0" algn="bl" rotWithShape="0" blurRad="38100" dist="25400" dir="2700000">
               <a:srgbClr val="CCCCCC">
                 <a:alpha val="30000"/>
               </a:srgbClr>
@@ -4374,8 +4387,8 @@
         </p:nvSpPr>
         <p:spPr>
           <a:xfrm>
-            <a:off x="7955280" y="1005840"/>
-            <a:ext cx="3931920" cy="54864"/>
+            <a:off x="6065520" y="822960"/>
+            <a:ext cx="2804160" cy="45720"/>
           </a:xfrm>
           <a:prstGeom prst="rect">
             <a:avLst/>
@@ -4394,8 +4407,8 @@
         </p:nvSpPr>
         <p:spPr>
           <a:xfrm>
-            <a:off x="7955280" y="1143000"/>
-            <a:ext cx="3931920" cy="457200"/>
+            <a:off x="6065520" y="914400"/>
+            <a:ext cx="2804160" cy="411480"/>
           </a:xfrm>
           <a:prstGeom prst="rect">
             <a:avLst/>
@@ -4411,14 +4424,14 @@
               <a:buNone/>
             </a:pPr>
             <a:r>
-              <a:rPr lang="en-US" sz="2600" dirty="0">
+              <a:rPr lang="en-US" sz="2200" dirty="0">
                 <a:solidFill>
                   <a:srgbClr val="000000"/>
                 </a:solidFill>
               </a:rPr>
               <a:t>📚</a:t>
             </a:r>
-            <a:endParaRPr lang="en-US" sz="2600" dirty="0"/>
+            <a:endParaRPr lang="en-US" sz="2200" dirty="0"/>
           </a:p>
         </p:txBody>
       </p:sp>
@@ -4430,8 +4443,8 @@
         </p:nvSpPr>
         <p:spPr>
           <a:xfrm>
-            <a:off x="8092440" y="1600200"/>
-            <a:ext cx="3657600" cy="320040"/>
+            <a:off x="6156960" y="1325880"/>
+            <a:ext cx="2621280" cy="274320"/>
           </a:xfrm>
           <a:prstGeom prst="rect">
             <a:avLst/>
@@ -4447,7 +4460,7 @@
               <a:buNone/>
             </a:pPr>
             <a:r>
-              <a:rPr lang="en-US" sz="1400" b="1" dirty="0">
+              <a:rPr lang="en-US" sz="1300" b="1" dirty="0">
                 <a:solidFill>
                   <a:srgbClr val="1A3A5C"/>
                 </a:solidFill>
@@ -4457,7 +4470,7 @@
               </a:rPr>
               <a:t>Commentaries</a:t>
             </a:r>
-            <a:endParaRPr lang="en-US" sz="1400" dirty="0"/>
+            <a:endParaRPr lang="en-US" sz="1300" dirty="0"/>
           </a:p>
         </p:txBody>
       </p:sp>
@@ -4469,8 +4482,8 @@
         </p:nvSpPr>
         <p:spPr>
           <a:xfrm>
-            <a:off x="8092440" y="1920240"/>
-            <a:ext cx="3657600" cy="2240280"/>
+            <a:off x="6156960" y="1600200"/>
+            <a:ext cx="2621280" cy="3154680"/>
           </a:xfrm>
           <a:prstGeom prst="rect">
             <a:avLst/>
@@ -4486,7 +4499,7 @@
               <a:buNone/>
             </a:pPr>
             <a:r>
-              <a:rPr lang="en-US" sz="1100" dirty="0">
+              <a:rPr lang="en-US" sz="1000" dirty="0">
                 <a:solidFill>
                   <a:srgbClr val="666666"/>
                 </a:solidFill>
@@ -4496,14 +4509,14 @@
               </a:rPr>
               <a:t>Any column can show:</a:t>
             </a:r>
-            <a:endParaRPr lang="en-US" sz="1100" dirty="0"/>
+            <a:endParaRPr lang="en-US" sz="1000" dirty="0"/>
           </a:p>
           <a:p>
             <a:pPr algn="ctr" indent="0" marL="0">
               <a:buNone/>
             </a:pPr>
             <a:r>
-              <a:rPr lang="en-US" sz="1100" dirty="0">
+              <a:rPr lang="en-US" sz="1000" dirty="0">
                 <a:solidFill>
                   <a:srgbClr val="666666"/>
                 </a:solidFill>
@@ -4513,14 +4526,14 @@
               </a:rPr>
               <a:t>• Bible commentary</a:t>
             </a:r>
-            <a:endParaRPr lang="en-US" sz="1100" dirty="0"/>
+            <a:endParaRPr lang="en-US" sz="1000" dirty="0"/>
           </a:p>
           <a:p>
             <a:pPr algn="ctr" indent="0" marL="0">
               <a:buNone/>
             </a:pPr>
             <a:r>
-              <a:rPr lang="en-US" sz="1100" dirty="0">
+              <a:rPr lang="en-US" sz="1000" dirty="0">
                 <a:solidFill>
                   <a:srgbClr val="666666"/>
                 </a:solidFill>
@@ -4530,14 +4543,14 @@
               </a:rPr>
               <a:t>• Quran commentary (Tafsir)</a:t>
             </a:r>
-            <a:endParaRPr lang="en-US" sz="1100" dirty="0"/>
+            <a:endParaRPr lang="en-US" sz="1000" dirty="0"/>
           </a:p>
           <a:p>
             <a:pPr algn="ctr" indent="0" marL="0">
               <a:buNone/>
             </a:pPr>
             <a:r>
-              <a:rPr lang="en-US" sz="1100" dirty="0">
+              <a:rPr lang="en-US" sz="1000" dirty="0">
                 <a:solidFill>
                   <a:srgbClr val="666666"/>
                 </a:solidFill>
@@ -4545,16 +4558,16 @@
                 <a:ea typeface="Arial" pitchFamily="34" charset="-122"/>
                 <a:cs typeface="Arial" pitchFamily="34" charset="-120"/>
               </a:rPr>
-              <a:t>• Cross-tradition comparative notes</a:t>
-            </a:r>
-            <a:endParaRPr lang="en-US" sz="1100" dirty="0"/>
+              <a:t>• Cross-tradition notes</a:t>
+            </a:r>
+            <a:endParaRPr lang="en-US" sz="1000" dirty="0"/>
           </a:p>
           <a:p>
             <a:pPr algn="ctr" indent="0" marL="0">
               <a:buNone/>
             </a:pPr>
             <a:r>
-              <a:rPr lang="en-US" sz="1100" dirty="0">
+              <a:rPr lang="en-US" sz="1000" dirty="0">
                 <a:solidFill>
                   <a:srgbClr val="666666"/>
                 </a:solidFill>
@@ -4564,7 +4577,7 @@
               </a:rPr>
               <a:t>• User personal notes</a:t>
             </a:r>
-            <a:endParaRPr lang="en-US" sz="1100" dirty="0"/>
+            <a:endParaRPr lang="en-US" sz="1000" dirty="0"/>
           </a:p>
         </p:txBody>
       </p:sp>
@@ -4576,8 +4589,8 @@
         </p:nvSpPr>
         <p:spPr>
           <a:xfrm>
-            <a:off x="457200" y="4434840"/>
-            <a:ext cx="11247120" cy="365760"/>
+            <a:off x="274320" y="4732020"/>
+            <a:ext cx="8595360" cy="274320"/>
           </a:xfrm>
           <a:prstGeom prst="rect">
             <a:avLst/>
@@ -4593,7 +4606,7 @@
               <a:buNone/>
             </a:pPr>
             <a:r>
-              <a:rPr lang="en-US" sz="1400" i="1" dirty="0">
+              <a:rPr lang="en-US" sz="1200" i="1" dirty="0">
                 <a:solidFill>
                   <a:srgbClr val="666666"/>
                 </a:solidFill>
@@ -4603,7 +4616,7 @@
               </a:rPr>
               <a:t>All traditions share the same column model — freely mix and match</a:t>
             </a:r>
-            <a:endParaRPr lang="en-US" sz="1400" dirty="0"/>
+            <a:endParaRPr lang="en-US" sz="1200" dirty="0"/>
           </a:p>
         </p:txBody>
       </p:sp>
@@ -4648,7 +4661,7 @@
         <p:spPr>
           <a:xfrm>
             <a:off x="0" y="0"/>
-            <a:ext cx="12161520" cy="822960"/>
+            <a:ext cx="9144000" cy="685800"/>
           </a:xfrm>
           <a:prstGeom prst="rect">
             <a:avLst/>
@@ -4667,8 +4680,8 @@
         </p:nvSpPr>
         <p:spPr>
           <a:xfrm>
-            <a:off x="0" y="822960"/>
-            <a:ext cx="12161520" cy="54864"/>
+            <a:off x="0" y="685800"/>
+            <a:ext cx="9144000" cy="45720"/>
           </a:xfrm>
           <a:prstGeom prst="rect">
             <a:avLst/>
@@ -4687,8 +4700,8 @@
         </p:nvSpPr>
         <p:spPr>
           <a:xfrm>
-            <a:off x="365760" y="45720"/>
-            <a:ext cx="11430000" cy="731520"/>
+            <a:off x="274320" y="45720"/>
+            <a:ext cx="8595360" cy="594360"/>
           </a:xfrm>
           <a:prstGeom prst="rect">
             <a:avLst/>
@@ -4704,7 +4717,7 @@
               <a:buNone/>
             </a:pPr>
             <a:r>
-              <a:rPr lang="en-US" sz="2400" b="1" dirty="0">
+              <a:rPr lang="en-US" sz="2200" b="1" dirty="0">
                 <a:solidFill>
                   <a:srgbClr val="FFFFFF"/>
                 </a:solidFill>
@@ -4714,7 +4727,7 @@
               </a:rPr>
               <a:t>Roadmap</a:t>
             </a:r>
-            <a:endParaRPr lang="en-US" sz="2400" dirty="0"/>
+            <a:endParaRPr lang="en-US" sz="2200" dirty="0"/>
           </a:p>
         </p:txBody>
       </p:sp>
@@ -4726,8 +4739,8 @@
         </p:nvSpPr>
         <p:spPr>
           <a:xfrm>
-            <a:off x="274320" y="960120"/>
-            <a:ext cx="2743200" cy="411480"/>
+            <a:off x="274320" y="822960"/>
+            <a:ext cx="2080260" cy="347472"/>
           </a:xfrm>
           <a:prstGeom prst="rect">
             <a:avLst/>
@@ -4751,8 +4764,8 @@
         </p:nvSpPr>
         <p:spPr>
           <a:xfrm>
-            <a:off x="274320" y="960120"/>
-            <a:ext cx="2743200" cy="411480"/>
+            <a:off x="274320" y="822960"/>
+            <a:ext cx="2080260" cy="347472"/>
           </a:xfrm>
           <a:prstGeom prst="rect">
             <a:avLst/>
@@ -4768,7 +4781,7 @@
               <a:buNone/>
             </a:pPr>
             <a:r>
-              <a:rPr lang="en-US" sz="1400" b="1" dirty="0">
+              <a:rPr lang="en-US" sz="1300" b="1" dirty="0">
                 <a:solidFill>
                   <a:srgbClr val="FFFFFF"/>
                 </a:solidFill>
@@ -4778,7 +4791,7 @@
               </a:rPr>
               <a:t>Now</a:t>
             </a:r>
-            <a:endParaRPr lang="en-US" sz="1400" dirty="0"/>
+            <a:endParaRPr lang="en-US" sz="1300" dirty="0"/>
           </a:p>
         </p:txBody>
       </p:sp>
@@ -4790,8 +4803,8 @@
         </p:nvSpPr>
         <p:spPr>
           <a:xfrm>
-            <a:off x="274320" y="1371600"/>
-            <a:ext cx="2743200" cy="3291840"/>
+            <a:off x="274320" y="1170432"/>
+            <a:ext cx="2080260" cy="3657600"/>
           </a:xfrm>
           <a:prstGeom prst="rect">
             <a:avLst/>
@@ -4815,8 +4828,8 @@
         </p:nvSpPr>
         <p:spPr>
           <a:xfrm>
-            <a:off x="365760" y="1417320"/>
-            <a:ext cx="2560320" cy="365760"/>
+            <a:off x="347472" y="1216152"/>
+            <a:ext cx="1933956" cy="320040"/>
           </a:xfrm>
           <a:prstGeom prst="rect">
             <a:avLst/>
@@ -4832,7 +4845,7 @@
               <a:buNone/>
             </a:pPr>
             <a:r>
-              <a:rPr lang="en-US" sz="1300" b="1" dirty="0">
+              <a:rPr lang="en-US" sz="1200" b="1" dirty="0">
                 <a:solidFill>
                   <a:srgbClr val="C9A84C"/>
                 </a:solidFill>
@@ -4842,7 +4855,7 @@
               </a:rPr>
               <a:t>Complete</a:t>
             </a:r>
-            <a:endParaRPr lang="en-US" sz="1300" dirty="0"/>
+            <a:endParaRPr lang="en-US" sz="1200" dirty="0"/>
           </a:p>
         </p:txBody>
       </p:sp>
@@ -4854,8 +4867,8 @@
         </p:nvSpPr>
         <p:spPr>
           <a:xfrm>
-            <a:off x="365760" y="1828800"/>
-            <a:ext cx="2560320" cy="2743200"/>
+            <a:off x="347472" y="1554480"/>
+            <a:ext cx="1933956" cy="3108960"/>
           </a:xfrm>
           <a:prstGeom prst="rect">
             <a:avLst/>
@@ -4871,7 +4884,7 @@
               <a:buNone/>
             </a:pPr>
             <a:r>
-              <a:rPr lang="en-US" sz="1100" dirty="0">
+              <a:rPr lang="en-US" sz="1000" dirty="0">
                 <a:solidFill>
                   <a:srgbClr val="666666"/>
                 </a:solidFill>
@@ -4881,14 +4894,14 @@
               </a:rPr>
               <a:t>• 6 Bible translations ingested</a:t>
             </a:r>
-            <a:endParaRPr lang="en-US" sz="1100" dirty="0"/>
+            <a:endParaRPr lang="en-US" sz="1000" dirty="0"/>
           </a:p>
           <a:p>
             <a:pPr indent="0" marL="0">
               <a:buNone/>
             </a:pPr>
             <a:r>
-              <a:rPr lang="en-US" sz="1100" dirty="0">
+              <a:rPr lang="en-US" sz="1000" dirty="0">
                 <a:solidFill>
                   <a:srgbClr val="666666"/>
                 </a:solidFill>
@@ -4898,14 +4911,14 @@
               </a:rPr>
               <a:t>• Multi-column reader working</a:t>
             </a:r>
-            <a:endParaRPr lang="en-US" sz="1100" dirty="0"/>
+            <a:endParaRPr lang="en-US" sz="1000" dirty="0"/>
           </a:p>
           <a:p>
             <a:pPr indent="0" marL="0">
               <a:buNone/>
             </a:pPr>
             <a:r>
-              <a:rPr lang="en-US" sz="1100" dirty="0">
+              <a:rPr lang="en-US" sz="1000" dirty="0">
                 <a:solidFill>
                   <a:srgbClr val="666666"/>
                 </a:solidFill>
@@ -4915,14 +4928,14 @@
               </a:rPr>
               <a:t>• Verse anchors &amp; sync</a:t>
             </a:r>
-            <a:endParaRPr lang="en-US" sz="1100" dirty="0"/>
+            <a:endParaRPr lang="en-US" sz="1000" dirty="0"/>
           </a:p>
           <a:p>
             <a:pPr indent="0" marL="0">
               <a:buNone/>
             </a:pPr>
             <a:r>
-              <a:rPr lang="en-US" sz="1100" dirty="0">
+              <a:rPr lang="en-US" sz="1000" dirty="0">
                 <a:solidFill>
                   <a:srgbClr val="666666"/>
                 </a:solidFill>
@@ -4930,9 +4943,9 @@
                 <a:ea typeface="Arial" pitchFamily="34" charset="-122"/>
                 <a:cs typeface="Arial" pitchFamily="34" charset="-120"/>
               </a:rPr>
-              <a:t>• Display modes (Original/Chapters/Verses/Titles)</a:t>
-            </a:r>
-            <a:endParaRPr lang="en-US" sz="1100" dirty="0"/>
+              <a:t>• Display modes</a:t>
+            </a:r>
+            <a:endParaRPr lang="en-US" sz="1000" dirty="0"/>
           </a:p>
         </p:txBody>
       </p:sp>
@@ -4944,8 +4957,8 @@
         </p:nvSpPr>
         <p:spPr>
           <a:xfrm>
-            <a:off x="3200400" y="960120"/>
-            <a:ext cx="2743200" cy="411480"/>
+            <a:off x="2446020" y="822960"/>
+            <a:ext cx="2080260" cy="347472"/>
           </a:xfrm>
           <a:prstGeom prst="rect">
             <a:avLst/>
@@ -4969,8 +4982,8 @@
         </p:nvSpPr>
         <p:spPr>
           <a:xfrm>
-            <a:off x="3200400" y="960120"/>
-            <a:ext cx="2743200" cy="411480"/>
+            <a:off x="2446020" y="822960"/>
+            <a:ext cx="2080260" cy="347472"/>
           </a:xfrm>
           <a:prstGeom prst="rect">
             <a:avLst/>
@@ -4986,7 +4999,7 @@
               <a:buNone/>
             </a:pPr>
             <a:r>
-              <a:rPr lang="en-US" sz="1400" b="1" dirty="0">
+              <a:rPr lang="en-US" sz="1300" b="1" dirty="0">
                 <a:solidFill>
                   <a:srgbClr val="FFFFFF"/>
                 </a:solidFill>
@@ -4996,7 +5009,7 @@
               </a:rPr>
               <a:t>Next</a:t>
             </a:r>
-            <a:endParaRPr lang="en-US" sz="1400" dirty="0"/>
+            <a:endParaRPr lang="en-US" sz="1300" dirty="0"/>
           </a:p>
         </p:txBody>
       </p:sp>
@@ -5008,8 +5021,8 @@
         </p:nvSpPr>
         <p:spPr>
           <a:xfrm>
-            <a:off x="3200400" y="1371600"/>
-            <a:ext cx="2743200" cy="3291840"/>
+            <a:off x="2446020" y="1170432"/>
+            <a:ext cx="2080260" cy="3657600"/>
           </a:xfrm>
           <a:prstGeom prst="rect">
             <a:avLst/>
@@ -5033,8 +5046,8 @@
         </p:nvSpPr>
         <p:spPr>
           <a:xfrm>
-            <a:off x="3291840" y="1417320"/>
-            <a:ext cx="2560320" cy="365760"/>
+            <a:off x="2519172" y="1216152"/>
+            <a:ext cx="1933956" cy="320040"/>
           </a:xfrm>
           <a:prstGeom prst="rect">
             <a:avLst/>
@@ -5050,7 +5063,7 @@
               <a:buNone/>
             </a:pPr>
             <a:r>
-              <a:rPr lang="en-US" sz="1300" b="1" dirty="0">
+              <a:rPr lang="en-US" sz="1200" b="1" dirty="0">
                 <a:solidFill>
                   <a:srgbClr val="1A3A5C"/>
                 </a:solidFill>
@@ -5060,7 +5073,7 @@
               </a:rPr>
               <a:t>Continuous Scroll</a:t>
             </a:r>
-            <a:endParaRPr lang="en-US" sz="1300" dirty="0"/>
+            <a:endParaRPr lang="en-US" sz="1200" dirty="0"/>
           </a:p>
         </p:txBody>
       </p:sp>
@@ -5072,8 +5085,8 @@
         </p:nvSpPr>
         <p:spPr>
           <a:xfrm>
-            <a:off x="3291840" y="1828800"/>
-            <a:ext cx="2560320" cy="2743200"/>
+            <a:off x="2519172" y="1554480"/>
+            <a:ext cx="1933956" cy="3108960"/>
           </a:xfrm>
           <a:prstGeom prst="rect">
             <a:avLst/>
@@ -5089,7 +5102,7 @@
               <a:buNone/>
             </a:pPr>
             <a:r>
-              <a:rPr lang="en-US" sz="1100" dirty="0">
+              <a:rPr lang="en-US" sz="1000" dirty="0">
                 <a:solidFill>
                   <a:srgbClr val="666666"/>
                 </a:solidFill>
@@ -5097,16 +5110,16 @@
                 <a:ea typeface="Arial" pitchFamily="34" charset="-122"/>
                 <a:cs typeface="Arial" pitchFamily="34" charset="-120"/>
               </a:rPr>
-              <a:t>• Infinite scroll Genesis → Revelation</a:t>
-            </a:r>
-            <a:endParaRPr lang="en-US" sz="1100" dirty="0"/>
+              <a:t>• Infinite scroll Genesis→Revelation</a:t>
+            </a:r>
+            <a:endParaRPr lang="en-US" sz="1000" dirty="0"/>
           </a:p>
           <a:p>
             <a:pPr indent="0" marL="0">
               <a:buNone/>
             </a:pPr>
             <a:r>
-              <a:rPr lang="en-US" sz="1100" dirty="0">
+              <a:rPr lang="en-US" sz="1000" dirty="0">
                 <a:solidFill>
                   <a:srgbClr val="666666"/>
                 </a:solidFill>
@@ -5114,16 +5127,16 @@
                 <a:ea typeface="Arial" pitchFamily="34" charset="-122"/>
                 <a:cs typeface="Arial" pitchFamily="34" charset="-120"/>
               </a:rPr>
-              <a:t>• Book-level DOM window (prev/current/next)</a:t>
-            </a:r>
-            <a:endParaRPr lang="en-US" sz="1100" dirty="0"/>
+              <a:t>• Book-level DOM window</a:t>
+            </a:r>
+            <a:endParaRPr lang="en-US" sz="1000" dirty="0"/>
           </a:p>
           <a:p>
             <a:pPr indent="0" marL="0">
               <a:buNone/>
             </a:pPr>
             <a:r>
-              <a:rPr lang="en-US" sz="1100" dirty="0">
+              <a:rPr lang="en-US" sz="1000" dirty="0">
                 <a:solidFill>
                   <a:srgbClr val="666666"/>
                 </a:solidFill>
@@ -5131,16 +5144,16 @@
                 <a:ea typeface="Arial" pitchFamily="34" charset="-122"/>
                 <a:cs typeface="Arial" pitchFamily="34" charset="-120"/>
               </a:rPr>
-              <a:t>• Chapter selector tracks scroll position</a:t>
-            </a:r>
-            <a:endParaRPr lang="en-US" sz="1100" dirty="0"/>
+              <a:t>• Chapter selector tracks scroll</a:t>
+            </a:r>
+            <a:endParaRPr lang="en-US" sz="1000" dirty="0"/>
           </a:p>
           <a:p>
             <a:pPr indent="0" marL="0">
               <a:buNone/>
             </a:pPr>
             <a:r>
-              <a:rPr lang="en-US" sz="1100" dirty="0">
+              <a:rPr lang="en-US" sz="1000" dirty="0">
                 <a:solidFill>
                   <a:srgbClr val="666666"/>
                 </a:solidFill>
@@ -5150,7 +5163,7 @@
               </a:rPr>
               <a:t>• Synced columns navigate together</a:t>
             </a:r>
-            <a:endParaRPr lang="en-US" sz="1100" dirty="0"/>
+            <a:endParaRPr lang="en-US" sz="1000" dirty="0"/>
           </a:p>
         </p:txBody>
       </p:sp>
@@ -5162,8 +5175,8 @@
         </p:nvSpPr>
         <p:spPr>
           <a:xfrm>
-            <a:off x="6126480" y="960120"/>
-            <a:ext cx="2743200" cy="411480"/>
+            <a:off x="4617720" y="822960"/>
+            <a:ext cx="2080260" cy="347472"/>
           </a:xfrm>
           <a:prstGeom prst="rect">
             <a:avLst/>
@@ -5187,8 +5200,8 @@
         </p:nvSpPr>
         <p:spPr>
           <a:xfrm>
-            <a:off x="6126480" y="960120"/>
-            <a:ext cx="2743200" cy="411480"/>
+            <a:off x="4617720" y="822960"/>
+            <a:ext cx="2080260" cy="347472"/>
           </a:xfrm>
           <a:prstGeom prst="rect">
             <a:avLst/>
@@ -5204,7 +5217,7 @@
               <a:buNone/>
             </a:pPr>
             <a:r>
-              <a:rPr lang="en-US" sz="1400" b="1" dirty="0">
+              <a:rPr lang="en-US" sz="1300" b="1" dirty="0">
                 <a:solidFill>
                   <a:srgbClr val="FFFFFF"/>
                 </a:solidFill>
@@ -5214,7 +5227,7 @@
               </a:rPr>
               <a:t>Soon</a:t>
             </a:r>
-            <a:endParaRPr lang="en-US" sz="1400" dirty="0"/>
+            <a:endParaRPr lang="en-US" sz="1300" dirty="0"/>
           </a:p>
         </p:txBody>
       </p:sp>
@@ -5226,8 +5239,8 @@
         </p:nvSpPr>
         <p:spPr>
           <a:xfrm>
-            <a:off x="6126480" y="1371600"/>
-            <a:ext cx="2743200" cy="3291840"/>
+            <a:off x="4617720" y="1170432"/>
+            <a:ext cx="2080260" cy="3657600"/>
           </a:xfrm>
           <a:prstGeom prst="rect">
             <a:avLst/>
@@ -5251,8 +5264,8 @@
         </p:nvSpPr>
         <p:spPr>
           <a:xfrm>
-            <a:off x="6217920" y="1417320"/>
-            <a:ext cx="2560320" cy="365760"/>
+            <a:off x="4690872" y="1216152"/>
+            <a:ext cx="1933956" cy="320040"/>
           </a:xfrm>
           <a:prstGeom prst="rect">
             <a:avLst/>
@@ -5268,7 +5281,7 @@
               <a:buNone/>
             </a:pPr>
             <a:r>
-              <a:rPr lang="en-US" sz="1300" b="1" dirty="0">
+              <a:rPr lang="en-US" sz="1200" b="1" dirty="0">
                 <a:solidFill>
                   <a:srgbClr val="2E7D32"/>
                 </a:solidFill>
@@ -5278,7 +5291,7 @@
               </a:rPr>
               <a:t>Cross-References</a:t>
             </a:r>
-            <a:endParaRPr lang="en-US" sz="1300" dirty="0"/>
+            <a:endParaRPr lang="en-US" sz="1200" dirty="0"/>
           </a:p>
         </p:txBody>
       </p:sp>
@@ -5290,8 +5303,8 @@
         </p:nvSpPr>
         <p:spPr>
           <a:xfrm>
-            <a:off x="6217920" y="1828800"/>
-            <a:ext cx="2560320" cy="2743200"/>
+            <a:off x="4690872" y="1554480"/>
+            <a:ext cx="1933956" cy="3108960"/>
           </a:xfrm>
           <a:prstGeom prst="rect">
             <a:avLst/>
@@ -5307,7 +5320,7 @@
               <a:buNone/>
             </a:pPr>
             <a:r>
-              <a:rPr lang="en-US" sz="1100" dirty="0">
+              <a:rPr lang="en-US" sz="1000" dirty="0">
                 <a:solidFill>
                   <a:srgbClr val="666666"/>
                 </a:solidFill>
@@ -5317,14 +5330,14 @@
               </a:rPr>
               <a:t>• Commentary links to verses</a:t>
             </a:r>
-            <a:endParaRPr lang="en-US" sz="1100" dirty="0"/>
+            <a:endParaRPr lang="en-US" sz="1000" dirty="0"/>
           </a:p>
           <a:p>
             <a:pPr indent="0" marL="0">
               <a:buNone/>
             </a:pPr>
             <a:r>
-              <a:rPr lang="en-US" sz="1100" dirty="0">
+              <a:rPr lang="en-US" sz="1000" dirty="0">
                 <a:solidFill>
                   <a:srgbClr val="666666"/>
                 </a:solidFill>
@@ -5332,16 +5345,16 @@
                 <a:ea typeface="Arial" pitchFamily="34" charset="-122"/>
                 <a:cs typeface="Arial" pitchFamily="34" charset="-120"/>
               </a:rPr>
-              <a:t>• Highlighted verse in all open columns</a:t>
-            </a:r>
-            <a:endParaRPr lang="en-US" sz="1100" dirty="0"/>
+              <a:t>• Highlight verse in all columns</a:t>
+            </a:r>
+            <a:endParaRPr lang="en-US" sz="1000" dirty="0"/>
           </a:p>
           <a:p>
             <a:pPr indent="0" marL="0">
               <a:buNone/>
             </a:pPr>
             <a:r>
-              <a:rPr lang="en-US" sz="1100" dirty="0">
+              <a:rPr lang="en-US" sz="1000" dirty="0">
                 <a:solidFill>
                   <a:srgbClr val="666666"/>
                 </a:solidFill>
@@ -5349,16 +5362,16 @@
                 <a:ea typeface="Arial" pitchFamily="34" charset="-122"/>
                 <a:cs typeface="Arial" pitchFamily="34" charset="-120"/>
               </a:rPr>
-              <a:t>• Auto-open column if text not visible</a:t>
-            </a:r>
-            <a:endParaRPr lang="en-US" sz="1100" dirty="0"/>
+              <a:t>• Auto-open column if needed</a:t>
+            </a:r>
+            <a:endParaRPr lang="en-US" sz="1000" dirty="0"/>
           </a:p>
           <a:p>
             <a:pPr indent="0" marL="0">
               <a:buNone/>
             </a:pPr>
             <a:r>
-              <a:rPr lang="en-US" sz="1100" dirty="0">
+              <a:rPr lang="en-US" sz="1000" dirty="0">
                 <a:solidFill>
                   <a:srgbClr val="666666"/>
                 </a:solidFill>
@@ -5366,9 +5379,9 @@
                 <a:ea typeface="Arial" pitchFamily="34" charset="-122"/>
                 <a:cs typeface="Arial" pitchFamily="34" charset="-120"/>
               </a:rPr>
-              <a:t>• Quran verse scheme (surah.ayah)</a:t>
-            </a:r>
-            <a:endParaRPr lang="en-US" sz="1100" dirty="0"/>
+              <a:t>• Quran verse scheme</a:t>
+            </a:r>
+            <a:endParaRPr lang="en-US" sz="1000" dirty="0"/>
           </a:p>
         </p:txBody>
       </p:sp>
@@ -5380,8 +5393,8 @@
         </p:nvSpPr>
         <p:spPr>
           <a:xfrm>
-            <a:off x="9052560" y="960120"/>
-            <a:ext cx="2743200" cy="411480"/>
+            <a:off x="6789420" y="822960"/>
+            <a:ext cx="2080260" cy="347472"/>
           </a:xfrm>
           <a:prstGeom prst="rect">
             <a:avLst/>
@@ -5405,8 +5418,8 @@
         </p:nvSpPr>
         <p:spPr>
           <a:xfrm>
-            <a:off x="9052560" y="960120"/>
-            <a:ext cx="2743200" cy="411480"/>
+            <a:off x="6789420" y="822960"/>
+            <a:ext cx="2080260" cy="347472"/>
           </a:xfrm>
           <a:prstGeom prst="rect">
             <a:avLst/>
@@ -5422,7 +5435,7 @@
               <a:buNone/>
             </a:pPr>
             <a:r>
-              <a:rPr lang="en-US" sz="1400" b="1" dirty="0">
+              <a:rPr lang="en-US" sz="1300" b="1" dirty="0">
                 <a:solidFill>
                   <a:srgbClr val="FFFFFF"/>
                 </a:solidFill>
@@ -5432,7 +5445,7 @@
               </a:rPr>
               <a:t>Later</a:t>
             </a:r>
-            <a:endParaRPr lang="en-US" sz="1400" dirty="0"/>
+            <a:endParaRPr lang="en-US" sz="1300" dirty="0"/>
           </a:p>
         </p:txBody>
       </p:sp>
@@ -5444,8 +5457,8 @@
         </p:nvSpPr>
         <p:spPr>
           <a:xfrm>
-            <a:off x="9052560" y="1371600"/>
-            <a:ext cx="2743200" cy="3291840"/>
+            <a:off x="6789420" y="1170432"/>
+            <a:ext cx="2080260" cy="3657600"/>
           </a:xfrm>
           <a:prstGeom prst="rect">
             <a:avLst/>
@@ -5469,8 +5482,8 @@
         </p:nvSpPr>
         <p:spPr>
           <a:xfrm>
-            <a:off x="9144000" y="1417320"/>
-            <a:ext cx="2560320" cy="365760"/>
+            <a:off x="6862572" y="1216152"/>
+            <a:ext cx="1933956" cy="320040"/>
           </a:xfrm>
           <a:prstGeom prst="rect">
             <a:avLst/>
@@ -5486,7 +5499,7 @@
               <a:buNone/>
             </a:pPr>
             <a:r>
-              <a:rPr lang="en-US" sz="1300" b="1" dirty="0">
+              <a:rPr lang="en-US" sz="1200" b="1" dirty="0">
                 <a:solidFill>
                   <a:srgbClr val="7B1FA2"/>
                 </a:solidFill>
@@ -5496,7 +5509,7 @@
               </a:rPr>
               <a:t>Full Platform</a:t>
             </a:r>
-            <a:endParaRPr lang="en-US" sz="1300" dirty="0"/>
+            <a:endParaRPr lang="en-US" sz="1200" dirty="0"/>
           </a:p>
         </p:txBody>
       </p:sp>
@@ -5508,8 +5521,8 @@
         </p:nvSpPr>
         <p:spPr>
           <a:xfrm>
-            <a:off x="9144000" y="1828800"/>
-            <a:ext cx="2560320" cy="2743200"/>
+            <a:off x="6862572" y="1554480"/>
+            <a:ext cx="1933956" cy="3108960"/>
           </a:xfrm>
           <a:prstGeom prst="rect">
             <a:avLst/>
@@ -5525,7 +5538,7 @@
               <a:buNone/>
             </a:pPr>
             <a:r>
-              <a:rPr lang="en-US" sz="1100" dirty="0">
+              <a:rPr lang="en-US" sz="1000" dirty="0">
                 <a:solidFill>
                   <a:srgbClr val="666666"/>
                 </a:solidFill>
@@ -5535,14 +5548,14 @@
               </a:rPr>
               <a:t>• User login &amp; personal notes</a:t>
             </a:r>
-            <a:endParaRPr lang="en-US" sz="1100" dirty="0"/>
+            <a:endParaRPr lang="en-US" sz="1000" dirty="0"/>
           </a:p>
           <a:p>
             <a:pPr indent="0" marL="0">
               <a:buNone/>
             </a:pPr>
             <a:r>
-              <a:rPr lang="en-US" sz="1100" dirty="0">
+              <a:rPr lang="en-US" sz="1000" dirty="0">
                 <a:solidFill>
                   <a:srgbClr val="666666"/>
                 </a:solidFill>
@@ -5552,14 +5565,14 @@
               </a:rPr>
               <a:t>• 200+ language bulk import</a:t>
             </a:r>
-            <a:endParaRPr lang="en-US" sz="1100" dirty="0"/>
+            <a:endParaRPr lang="en-US" sz="1000" dirty="0"/>
           </a:p>
           <a:p>
             <a:pPr indent="0" marL="0">
               <a:buNone/>
             </a:pPr>
             <a:r>
-              <a:rPr lang="en-US" sz="1100" dirty="0">
+              <a:rPr lang="en-US" sz="1000" dirty="0">
                 <a:solidFill>
                   <a:srgbClr val="666666"/>
                 </a:solidFill>
@@ -5569,14 +5582,14 @@
               </a:rPr>
               <a:t>• Quran + Hadith ingestion</a:t>
             </a:r>
-            <a:endParaRPr lang="en-US" sz="1100" dirty="0"/>
+            <a:endParaRPr lang="en-US" sz="1000" dirty="0"/>
           </a:p>
           <a:p>
             <a:pPr indent="0" marL="0">
               <a:buNone/>
             </a:pPr>
             <a:r>
-              <a:rPr lang="en-US" sz="1100" dirty="0">
+              <a:rPr lang="en-US" sz="1000" dirty="0">
                 <a:solidFill>
                   <a:srgbClr val="666666"/>
                 </a:solidFill>
@@ -5586,7 +5599,7 @@
               </a:rPr>
               <a:t>• Search across all texts</a:t>
             </a:r>
-            <a:endParaRPr lang="en-US" sz="1100" dirty="0"/>
+            <a:endParaRPr lang="en-US" sz="1000" dirty="0"/>
           </a:p>
         </p:txBody>
       </p:sp>
@@ -5630,8 +5643,8 @@
         </p:nvSpPr>
         <p:spPr>
           <a:xfrm>
-            <a:off x="0" y="2377440"/>
-            <a:ext cx="12161520" cy="73152"/>
+            <a:off x="0" y="2535174"/>
+            <a:ext cx="9144000" cy="73152"/>
           </a:xfrm>
           <a:prstGeom prst="rect">
             <a:avLst/>
@@ -5650,8 +5663,8 @@
         </p:nvSpPr>
         <p:spPr>
           <a:xfrm>
-            <a:off x="731520" y="1280160"/>
-            <a:ext cx="10698480" cy="914400"/>
+            <a:off x="274320" y="1097280"/>
+            <a:ext cx="8595360" cy="822960"/>
           </a:xfrm>
           <a:prstGeom prst="rect">
             <a:avLst/>
@@ -5667,7 +5680,7 @@
               <a:buNone/>
             </a:pPr>
             <a:r>
-              <a:rPr lang="en-US" sz="4400" b="1" dirty="0">
+              <a:rPr lang="en-US" sz="3800" b="1" dirty="0">
                 <a:solidFill>
                   <a:srgbClr val="FFFFFF"/>
                 </a:solidFill>
@@ -5677,7 +5690,7 @@
               </a:rPr>
               <a:t>Built for serious study.</a:t>
             </a:r>
-            <a:endParaRPr lang="en-US" sz="4400" dirty="0"/>
+            <a:endParaRPr lang="en-US" sz="3800" dirty="0"/>
           </a:p>
         </p:txBody>
       </p:sp>
@@ -5689,8 +5702,8 @@
         </p:nvSpPr>
         <p:spPr>
           <a:xfrm>
-            <a:off x="731520" y="2560320"/>
-            <a:ext cx="10698480" cy="640080"/>
+            <a:off x="274320" y="2651760"/>
+            <a:ext cx="8595360" cy="548640"/>
           </a:xfrm>
           <a:prstGeom prst="rect">
             <a:avLst/>
@@ -5706,7 +5719,7 @@
               <a:buNone/>
             </a:pPr>
             <a:r>
-              <a:rPr lang="en-US" sz="2200" i="1" dirty="0">
+              <a:rPr lang="en-US" sz="1800" i="1" dirty="0">
                 <a:solidFill>
                   <a:srgbClr val="C9A84C"/>
                 </a:solidFill>
@@ -5716,7 +5729,7 @@
               </a:rPr>
               <a:t>Every tradition. Every translation. Side by side.</a:t>
             </a:r>
-            <a:endParaRPr lang="en-US" sz="2200" dirty="0"/>
+            <a:endParaRPr lang="en-US" sz="1800" dirty="0"/>
           </a:p>
         </p:txBody>
       </p:sp>
@@ -5728,8 +5741,8 @@
         </p:nvSpPr>
         <p:spPr>
           <a:xfrm>
-            <a:off x="731520" y="4663440"/>
-            <a:ext cx="10698480" cy="320040"/>
+            <a:off x="274320" y="4640580"/>
+            <a:ext cx="8595360" cy="320040"/>
           </a:xfrm>
           <a:prstGeom prst="rect">
             <a:avLst/>
@@ -5745,7 +5758,7 @@
               <a:buNone/>
             </a:pPr>
             <a:r>
-              <a:rPr lang="en-US" sz="1300" dirty="0">
+              <a:rPr lang="en-US" sz="1200" dirty="0">
                 <a:solidFill>
                   <a:srgbClr val="FFFFFF"/>
                 </a:solidFill>
@@ -5755,7 +5768,7 @@
               </a:rPr>
               <a:t>Religious Texts Platform  |  May 2026</a:t>
             </a:r>
-            <a:endParaRPr lang="en-US" sz="1300" dirty="0"/>
+            <a:endParaRPr lang="en-US" sz="1200" dirty="0"/>
           </a:p>
         </p:txBody>
       </p:sp>

</xml_diff>